<commit_message>
Complete pancreatic cancer survival analysis project
</commit_message>
<xml_diff>
--- a/outputs/survival_project_presentation.pptx
+++ b/outputs/survival_project_presentation.pptx
@@ -2,19 +2,19 @@
 <file path=ppt/presentation.xml><?xml version="1.0" encoding="utf-8"?>
 <p:presentation xmlns:p="http://schemas.openxmlformats.org/presentationml/2006/main">
   <p:sldMasterIdLst>
-    <p:sldMasterId xmlns:r="http://schemas.openxmlformats.org/officeDocument/2006/relationships" id="2147483648" r:id="Rb711eb72ea3a4fbc"/>
+    <p:sldMasterId xmlns:r="http://schemas.openxmlformats.org/officeDocument/2006/relationships" id="2147483648" r:id="R3932dc241fdf4b3d"/>
   </p:sldMasterIdLst>
   <p:notesMasterIdLst>
-    <p:notesMasterId xmlns:r="http://schemas.openxmlformats.org/officeDocument/2006/relationships" r:id="R47b13d2807054a0a"/>
+    <p:notesMasterId xmlns:r="http://schemas.openxmlformats.org/officeDocument/2006/relationships" r:id="R8d7e21cb77cf4449"/>
   </p:notesMasterIdLst>
   <p:sldIdLst>
-    <p:sldId xmlns:r="http://schemas.openxmlformats.org/officeDocument/2006/relationships" id="256" r:id="R177282d8b51e4020"/>
-    <p:sldId xmlns:r="http://schemas.openxmlformats.org/officeDocument/2006/relationships" id="257" r:id="R36a29028686040f2"/>
-    <p:sldId xmlns:r="http://schemas.openxmlformats.org/officeDocument/2006/relationships" id="258" r:id="R42c91c03e8004ebc"/>
-    <p:sldId xmlns:r="http://schemas.openxmlformats.org/officeDocument/2006/relationships" id="259" r:id="R27239b080ee54d5e"/>
-    <p:sldId xmlns:r="http://schemas.openxmlformats.org/officeDocument/2006/relationships" id="260" r:id="R4c72986e8998407b"/>
-    <p:sldId xmlns:r="http://schemas.openxmlformats.org/officeDocument/2006/relationships" id="261" r:id="R469a253598a44c1d"/>
-    <p:sldId xmlns:r="http://schemas.openxmlformats.org/officeDocument/2006/relationships" id="262" r:id="Rb91fb77d84f549ff"/>
+    <p:sldId xmlns:r="http://schemas.openxmlformats.org/officeDocument/2006/relationships" id="256" r:id="R078dd07be1004f0b"/>
+    <p:sldId xmlns:r="http://schemas.openxmlformats.org/officeDocument/2006/relationships" id="257" r:id="Re2096063f0394ed4"/>
+    <p:sldId xmlns:r="http://schemas.openxmlformats.org/officeDocument/2006/relationships" id="258" r:id="R0be60ffe04064273"/>
+    <p:sldId xmlns:r="http://schemas.openxmlformats.org/officeDocument/2006/relationships" id="259" r:id="R49e0968b372044b0"/>
+    <p:sldId xmlns:r="http://schemas.openxmlformats.org/officeDocument/2006/relationships" id="260" r:id="R19866541471a4005"/>
+    <p:sldId xmlns:r="http://schemas.openxmlformats.org/officeDocument/2006/relationships" id="261" r:id="R40e61488720744e9"/>
+    <p:sldId xmlns:r="http://schemas.openxmlformats.org/officeDocument/2006/relationships" id="262" r:id="R9b639955efa942f9"/>
   </p:sldIdLst>
   <p:sldSz cx="12192000" cy="6858000"/>
   <p:notesSz cx="6858000" cy="9144000"/>
@@ -867,6 +867,31 @@
               <a:t>Data source: TCGA Pan-Cancer Clinical Data Resource, NCI GDC, https://gdc.cancer.gov/about-data/publications/PanCan-Clinical-2018. The assignment guidelines require a private GitHub repository, two-page PDF write-up, presentation and live demonstration. Add team member names and the assigned serial-number problem before submission.</a:t>
             </a:r>
           </a:p>
+          <a:p xmlns:a="http://schemas.openxmlformats.org/drawingml/2006/main">
+            <a:r>
+              <a:t/>
+            </a:r>
+          </a:p>
+          <a:p xmlns:a="http://schemas.openxmlformats.org/drawingml/2006/main">
+            <a:r>
+              <a:t>Nested tuning method: 5-fold stratified outer CV; within each training fold, a 3-fold grid search selected hyperparameters by balanced accuracy.</a:t>
+            </a:r>
+          </a:p>
+          <a:p xmlns:a="http://schemas.openxmlformats.org/drawingml/2006/main">
+            <a:r>
+              <a:t>TCGA tuned OOF results: LR bAcc 0.624 / AUC 0.623; SVM 0.618 / 0.593; NB 0.606 / 0.614; RF 0.512 / 0.568; Gradient Boosting 0.489 / 0.581.</a:t>
+            </a:r>
+          </a:p>
+          <a:p xmlns:a="http://schemas.openxmlformats.org/drawingml/2006/main">
+            <a:r>
+              <a:t>MSK tuned OOF results: SVM bAcc 0.661 / AUC 0.675; RF 0.658 / 0.689; NB 0.652 / 0.682; LR 0.650 / 0.692; Gradient Boosting 0.537 / 0.664.</a:t>
+            </a:r>
+          </a:p>
+          <a:p xmlns:a="http://schemas.openxmlformats.org/drawingml/2006/main">
+            <a:r>
+              <a:t>Fold-specific settings and inner scores are in classifier_tuned_params.csv under each output cohort directory.</a:t>
+            </a:r>
+          </a:p>
         </p:txBody>
       </p:sp>
       <p:sp>
@@ -941,16 +966,6 @@
             <a:normAutofit/>
           </a:bodyPr>
           <a:lstStyle xmlns:a="http://schemas.openxmlformats.org/drawingml/2006/main">
-            <a:defPPr algn="ctr">
-              <a:defRPr sz="4800" b="1">
-                <a:solidFill>
-                  <a:schemeClr val="tx1"/>
-                </a:solidFill>
-                <a:latin typeface="+mj-lt"/>
-                <a:ea typeface="+mj-lt"/>
-                <a:cs typeface="+mj-lt"/>
-              </a:defRPr>
-            </a:defPPr>
             <a:lvl1pPr marL="0" indent="0">
               <a:lnSpc>
                 <a:spcPct val="110000"/>
@@ -962,6 +977,7 @@
                 <a:spcPts val="0"/>
               </a:spcAft>
               <a:buNone/>
+              <a:defRPr/>
             </a:lvl1pPr>
             <a:lvl2pPr marL="0" indent="0">
               <a:lnSpc>
@@ -974,6 +990,7 @@
                 <a:spcPts val="0"/>
               </a:spcAft>
               <a:buNone/>
+              <a:defRPr/>
             </a:lvl2pPr>
             <a:lvl3pPr marL="0" indent="0">
               <a:lnSpc>
@@ -986,6 +1003,7 @@
                 <a:spcPts val="0"/>
               </a:spcAft>
               <a:buNone/>
+              <a:defRPr/>
             </a:lvl3pPr>
             <a:lvl4pPr marL="0" indent="0">
               <a:lnSpc>
@@ -998,6 +1016,7 @@
                 <a:spcPts val="0"/>
               </a:spcAft>
               <a:buNone/>
+              <a:defRPr/>
             </a:lvl4pPr>
             <a:lvl5pPr marL="0" indent="0">
               <a:lnSpc>
@@ -1010,6 +1029,7 @@
                 <a:spcPts val="0"/>
               </a:spcAft>
               <a:buNone/>
+              <a:defRPr/>
             </a:lvl5pPr>
             <a:lvl6pPr marL="0" indent="0">
               <a:lnSpc>
@@ -1022,6 +1042,7 @@
                 <a:spcPts val="0"/>
               </a:spcAft>
               <a:buNone/>
+              <a:defRPr/>
             </a:lvl6pPr>
             <a:lvl7pPr marL="0" indent="0">
               <a:lnSpc>
@@ -1034,6 +1055,7 @@
                 <a:spcPts val="0"/>
               </a:spcAft>
               <a:buNone/>
+              <a:defRPr/>
             </a:lvl7pPr>
             <a:lvl8pPr marL="0" indent="0">
               <a:lnSpc>
@@ -1046,6 +1068,7 @@
                 <a:spcPts val="0"/>
               </a:spcAft>
               <a:buNone/>
+              <a:defRPr/>
             </a:lvl8pPr>
             <a:lvl9pPr marL="0" indent="0">
               <a:lnSpc>
@@ -1058,6 +1081,7 @@
                 <a:spcPts val="0"/>
               </a:spcAft>
               <a:buNone/>
+              <a:defRPr/>
             </a:lvl9pPr>
           </a:lstStyle>
           <a:p xmlns:a="http://schemas.openxmlformats.org/drawingml/2006/main"/>
@@ -1098,16 +1122,6 @@
             <a:normAutofit/>
           </a:bodyPr>
           <a:lstStyle xmlns:a="http://schemas.openxmlformats.org/drawingml/2006/main">
-            <a:defPPr algn="ctr">
-              <a:defRPr sz="2100" b="0">
-                <a:solidFill>
-                  <a:schemeClr val="tx1"/>
-                </a:solidFill>
-                <a:latin typeface="+mn-lt"/>
-                <a:ea typeface="+mn-lt"/>
-                <a:cs typeface="+mn-lt"/>
-              </a:defRPr>
-            </a:defPPr>
             <a:lvl1pPr marL="0" indent="0">
               <a:lnSpc>
                 <a:spcPct val="110000"/>
@@ -1119,6 +1133,7 @@
                 <a:spcPts val="0"/>
               </a:spcAft>
               <a:buNone/>
+              <a:defRPr/>
             </a:lvl1pPr>
             <a:lvl2pPr marL="0" indent="0">
               <a:lnSpc>
@@ -1131,6 +1146,7 @@
                 <a:spcPts val="0"/>
               </a:spcAft>
               <a:buNone/>
+              <a:defRPr/>
             </a:lvl2pPr>
             <a:lvl3pPr marL="0" indent="0">
               <a:lnSpc>
@@ -1143,6 +1159,7 @@
                 <a:spcPts val="0"/>
               </a:spcAft>
               <a:buNone/>
+              <a:defRPr/>
             </a:lvl3pPr>
             <a:lvl4pPr marL="0" indent="0">
               <a:lnSpc>
@@ -1155,6 +1172,7 @@
                 <a:spcPts val="0"/>
               </a:spcAft>
               <a:buNone/>
+              <a:defRPr/>
             </a:lvl4pPr>
             <a:lvl5pPr marL="0" indent="0">
               <a:lnSpc>
@@ -1167,6 +1185,7 @@
                 <a:spcPts val="0"/>
               </a:spcAft>
               <a:buNone/>
+              <a:defRPr/>
             </a:lvl5pPr>
             <a:lvl6pPr marL="0" indent="0">
               <a:lnSpc>
@@ -1179,6 +1198,7 @@
                 <a:spcPts val="0"/>
               </a:spcAft>
               <a:buNone/>
+              <a:defRPr/>
             </a:lvl6pPr>
             <a:lvl7pPr marL="0" indent="0">
               <a:lnSpc>
@@ -1191,6 +1211,7 @@
                 <a:spcPts val="0"/>
               </a:spcAft>
               <a:buNone/>
+              <a:defRPr/>
             </a:lvl7pPr>
             <a:lvl8pPr marL="0" indent="0">
               <a:lnSpc>
@@ -1203,6 +1224,7 @@
                 <a:spcPts val="0"/>
               </a:spcAft>
               <a:buNone/>
+              <a:defRPr/>
             </a:lvl8pPr>
             <a:lvl9pPr marL="0" indent="0">
               <a:lnSpc>
@@ -1215,6 +1237,7 @@
                 <a:spcPts val="0"/>
               </a:spcAft>
               <a:buNone/>
+              <a:defRPr/>
             </a:lvl9pPr>
           </a:lstStyle>
           <a:p xmlns:a="http://schemas.openxmlformats.org/drawingml/2006/main"/>
@@ -1272,16 +1295,6 @@
             <a:normAutofit/>
           </a:bodyPr>
           <a:lstStyle xmlns:a="http://schemas.openxmlformats.org/drawingml/2006/main">
-            <a:defPPr algn="ctr">
-              <a:defRPr sz="4200" b="1">
-                <a:solidFill>
-                  <a:schemeClr val="tx1"/>
-                </a:solidFill>
-                <a:latin typeface="+mj-lt"/>
-                <a:ea typeface="+mj-lt"/>
-                <a:cs typeface="+mj-lt"/>
-              </a:defRPr>
-            </a:defPPr>
             <a:lvl1pPr marL="0" indent="0">
               <a:lnSpc>
                 <a:spcPct val="110000"/>
@@ -1293,6 +1306,7 @@
                 <a:spcPts val="0"/>
               </a:spcAft>
               <a:buNone/>
+              <a:defRPr/>
             </a:lvl1pPr>
             <a:lvl2pPr marL="0" indent="0">
               <a:lnSpc>
@@ -1305,6 +1319,7 @@
                 <a:spcPts val="0"/>
               </a:spcAft>
               <a:buNone/>
+              <a:defRPr/>
             </a:lvl2pPr>
             <a:lvl3pPr marL="0" indent="0">
               <a:lnSpc>
@@ -1317,6 +1332,7 @@
                 <a:spcPts val="0"/>
               </a:spcAft>
               <a:buNone/>
+              <a:defRPr/>
             </a:lvl3pPr>
             <a:lvl4pPr marL="0" indent="0">
               <a:lnSpc>
@@ -1329,6 +1345,7 @@
                 <a:spcPts val="0"/>
               </a:spcAft>
               <a:buNone/>
+              <a:defRPr/>
             </a:lvl4pPr>
             <a:lvl5pPr marL="0" indent="0">
               <a:lnSpc>
@@ -1341,6 +1358,7 @@
                 <a:spcPts val="0"/>
               </a:spcAft>
               <a:buNone/>
+              <a:defRPr/>
             </a:lvl5pPr>
             <a:lvl6pPr marL="0" indent="0">
               <a:lnSpc>
@@ -1353,6 +1371,7 @@
                 <a:spcPts val="0"/>
               </a:spcAft>
               <a:buNone/>
+              <a:defRPr/>
             </a:lvl6pPr>
             <a:lvl7pPr marL="0" indent="0">
               <a:lnSpc>
@@ -1365,6 +1384,7 @@
                 <a:spcPts val="0"/>
               </a:spcAft>
               <a:buNone/>
+              <a:defRPr/>
             </a:lvl7pPr>
             <a:lvl8pPr marL="0" indent="0">
               <a:lnSpc>
@@ -1377,6 +1397,7 @@
                 <a:spcPts val="0"/>
               </a:spcAft>
               <a:buNone/>
+              <a:defRPr/>
             </a:lvl8pPr>
             <a:lvl9pPr marL="0" indent="0">
               <a:lnSpc>
@@ -1389,6 +1410,7 @@
                 <a:spcPts val="0"/>
               </a:spcAft>
               <a:buNone/>
+              <a:defRPr/>
             </a:lvl9pPr>
           </a:lstStyle>
           <a:p xmlns:a="http://schemas.openxmlformats.org/drawingml/2006/main"/>
@@ -1446,16 +1468,6 @@
             <a:normAutofit/>
           </a:bodyPr>
           <a:lstStyle xmlns:a="http://schemas.openxmlformats.org/drawingml/2006/main">
-            <a:defPPr algn="l">
-              <a:defRPr sz="3300" b="1">
-                <a:solidFill>
-                  <a:schemeClr val="tx1"/>
-                </a:solidFill>
-                <a:latin typeface="+mj-lt"/>
-                <a:ea typeface="+mj-lt"/>
-                <a:cs typeface="+mj-lt"/>
-              </a:defRPr>
-            </a:defPPr>
             <a:lvl1pPr marL="0" indent="0">
               <a:lnSpc>
                 <a:spcPct val="110000"/>
@@ -1467,6 +1479,7 @@
                 <a:spcPts val="0"/>
               </a:spcAft>
               <a:buNone/>
+              <a:defRPr/>
             </a:lvl1pPr>
             <a:lvl2pPr marL="0" indent="0">
               <a:lnSpc>
@@ -1479,6 +1492,7 @@
                 <a:spcPts val="0"/>
               </a:spcAft>
               <a:buNone/>
+              <a:defRPr/>
             </a:lvl2pPr>
             <a:lvl3pPr marL="0" indent="0">
               <a:lnSpc>
@@ -1491,6 +1505,7 @@
                 <a:spcPts val="0"/>
               </a:spcAft>
               <a:buNone/>
+              <a:defRPr/>
             </a:lvl3pPr>
             <a:lvl4pPr marL="0" indent="0">
               <a:lnSpc>
@@ -1503,6 +1518,7 @@
                 <a:spcPts val="0"/>
               </a:spcAft>
               <a:buNone/>
+              <a:defRPr/>
             </a:lvl4pPr>
             <a:lvl5pPr marL="0" indent="0">
               <a:lnSpc>
@@ -1515,6 +1531,7 @@
                 <a:spcPts val="0"/>
               </a:spcAft>
               <a:buNone/>
+              <a:defRPr/>
             </a:lvl5pPr>
             <a:lvl6pPr marL="0" indent="0">
               <a:lnSpc>
@@ -1527,6 +1544,7 @@
                 <a:spcPts val="0"/>
               </a:spcAft>
               <a:buNone/>
+              <a:defRPr/>
             </a:lvl6pPr>
             <a:lvl7pPr marL="0" indent="0">
               <a:lnSpc>
@@ -1539,6 +1557,7 @@
                 <a:spcPts val="0"/>
               </a:spcAft>
               <a:buNone/>
+              <a:defRPr/>
             </a:lvl7pPr>
             <a:lvl8pPr marL="0" indent="0">
               <a:lnSpc>
@@ -1551,6 +1570,7 @@
                 <a:spcPts val="0"/>
               </a:spcAft>
               <a:buNone/>
+              <a:defRPr/>
             </a:lvl8pPr>
             <a:lvl9pPr marL="0" indent="0">
               <a:lnSpc>
@@ -1563,6 +1583,7 @@
                 <a:spcPts val="0"/>
               </a:spcAft>
               <a:buNone/>
+              <a:defRPr/>
             </a:lvl9pPr>
           </a:lstStyle>
           <a:p xmlns:a="http://schemas.openxmlformats.org/drawingml/2006/main"/>
@@ -1603,16 +1624,6 @@
             <a:normAutofit/>
           </a:bodyPr>
           <a:lstStyle xmlns:a="http://schemas.openxmlformats.org/drawingml/2006/main">
-            <a:defPPr algn="l">
-              <a:defRPr sz="2250" b="0">
-                <a:solidFill>
-                  <a:schemeClr val="tx1"/>
-                </a:solidFill>
-                <a:latin typeface="+mn-lt"/>
-                <a:ea typeface="+mn-lt"/>
-                <a:cs typeface="+mn-lt"/>
-              </a:defRPr>
-            </a:defPPr>
             <a:lvl1pPr marL="228600" indent="-228600">
               <a:lnSpc>
                 <a:spcPct val="110000"/>
@@ -1624,6 +1635,7 @@
                 <a:spcPts val="1200"/>
               </a:spcAft>
               <a:buChar char="•"/>
+              <a:defRPr/>
             </a:lvl1pPr>
             <a:lvl2pPr marL="533400" indent="-228600">
               <a:lnSpc>
@@ -1636,6 +1648,7 @@
                 <a:spcPts val="1200"/>
               </a:spcAft>
               <a:buChar char="•"/>
+              <a:defRPr/>
             </a:lvl2pPr>
             <a:lvl3pPr marL="838200" indent="-228600">
               <a:lnSpc>
@@ -1648,6 +1661,7 @@
                 <a:spcPts val="1200"/>
               </a:spcAft>
               <a:buChar char="•"/>
+              <a:defRPr/>
             </a:lvl3pPr>
             <a:lvl4pPr marL="1143000" indent="-228600">
               <a:lnSpc>
@@ -1660,6 +1674,7 @@
                 <a:spcPts val="1200"/>
               </a:spcAft>
               <a:buChar char="•"/>
+              <a:defRPr/>
             </a:lvl4pPr>
             <a:lvl5pPr marL="1447800" indent="-228600">
               <a:lnSpc>
@@ -1672,6 +1687,7 @@
                 <a:spcPts val="1200"/>
               </a:spcAft>
               <a:buChar char="•"/>
+              <a:defRPr/>
             </a:lvl5pPr>
             <a:lvl6pPr marL="1752600" indent="-228600">
               <a:lnSpc>
@@ -1684,6 +1700,7 @@
                 <a:spcPts val="1200"/>
               </a:spcAft>
               <a:buChar char="•"/>
+              <a:defRPr/>
             </a:lvl6pPr>
             <a:lvl7pPr marL="2057400" indent="-228600">
               <a:lnSpc>
@@ -1696,6 +1713,7 @@
                 <a:spcPts val="1200"/>
               </a:spcAft>
               <a:buChar char="•"/>
+              <a:defRPr/>
             </a:lvl7pPr>
             <a:lvl8pPr marL="2362200" indent="-228600">
               <a:lnSpc>
@@ -1708,6 +1726,7 @@
                 <a:spcPts val="1200"/>
               </a:spcAft>
               <a:buChar char="•"/>
+              <a:defRPr/>
             </a:lvl8pPr>
             <a:lvl9pPr marL="2667000" indent="-228600">
               <a:lnSpc>
@@ -1720,6 +1739,7 @@
                 <a:spcPts val="1200"/>
               </a:spcAft>
               <a:buChar char="•"/>
+              <a:defRPr/>
             </a:lvl9pPr>
           </a:lstStyle>
           <a:p xmlns:a="http://schemas.openxmlformats.org/drawingml/2006/main"/>
@@ -1777,16 +1797,6 @@
             <a:normAutofit/>
           </a:bodyPr>
           <a:lstStyle xmlns:a="http://schemas.openxmlformats.org/drawingml/2006/main">
-            <a:defPPr algn="l">
-              <a:defRPr sz="3300" b="1">
-                <a:solidFill>
-                  <a:schemeClr val="tx1"/>
-                </a:solidFill>
-                <a:latin typeface="+mj-lt"/>
-                <a:ea typeface="+mj-lt"/>
-                <a:cs typeface="+mj-lt"/>
-              </a:defRPr>
-            </a:defPPr>
             <a:lvl1pPr marL="0" indent="0">
               <a:lnSpc>
                 <a:spcPct val="110000"/>
@@ -1798,6 +1808,7 @@
                 <a:spcPts val="0"/>
               </a:spcAft>
               <a:buNone/>
+              <a:defRPr/>
             </a:lvl1pPr>
             <a:lvl2pPr marL="0" indent="0">
               <a:lnSpc>
@@ -1810,6 +1821,7 @@
                 <a:spcPts val="0"/>
               </a:spcAft>
               <a:buNone/>
+              <a:defRPr/>
             </a:lvl2pPr>
             <a:lvl3pPr marL="0" indent="0">
               <a:lnSpc>
@@ -1822,6 +1834,7 @@
                 <a:spcPts val="0"/>
               </a:spcAft>
               <a:buNone/>
+              <a:defRPr/>
             </a:lvl3pPr>
             <a:lvl4pPr marL="0" indent="0">
               <a:lnSpc>
@@ -1834,6 +1847,7 @@
                 <a:spcPts val="0"/>
               </a:spcAft>
               <a:buNone/>
+              <a:defRPr/>
             </a:lvl4pPr>
             <a:lvl5pPr marL="0" indent="0">
               <a:lnSpc>
@@ -1846,6 +1860,7 @@
                 <a:spcPts val="0"/>
               </a:spcAft>
               <a:buNone/>
+              <a:defRPr/>
             </a:lvl5pPr>
             <a:lvl6pPr marL="0" indent="0">
               <a:lnSpc>
@@ -1858,6 +1873,7 @@
                 <a:spcPts val="0"/>
               </a:spcAft>
               <a:buNone/>
+              <a:defRPr/>
             </a:lvl6pPr>
             <a:lvl7pPr marL="0" indent="0">
               <a:lnSpc>
@@ -1870,6 +1886,7 @@
                 <a:spcPts val="0"/>
               </a:spcAft>
               <a:buNone/>
+              <a:defRPr/>
             </a:lvl7pPr>
             <a:lvl8pPr marL="0" indent="0">
               <a:lnSpc>
@@ -1882,6 +1899,7 @@
                 <a:spcPts val="0"/>
               </a:spcAft>
               <a:buNone/>
+              <a:defRPr/>
             </a:lvl8pPr>
             <a:lvl9pPr marL="0" indent="0">
               <a:lnSpc>
@@ -1894,6 +1912,7 @@
                 <a:spcPts val="0"/>
               </a:spcAft>
               <a:buNone/>
+              <a:defRPr/>
             </a:lvl9pPr>
           </a:lstStyle>
           <a:p xmlns:a="http://schemas.openxmlformats.org/drawingml/2006/main"/>
@@ -1934,16 +1953,6 @@
             <a:normAutofit/>
           </a:bodyPr>
           <a:lstStyle xmlns:a="http://schemas.openxmlformats.org/drawingml/2006/main">
-            <a:defPPr algn="l">
-              <a:defRPr sz="2100" b="0">
-                <a:solidFill>
-                  <a:schemeClr val="tx1"/>
-                </a:solidFill>
-                <a:latin typeface="+mn-lt"/>
-                <a:ea typeface="+mn-lt"/>
-                <a:cs typeface="+mn-lt"/>
-              </a:defRPr>
-            </a:defPPr>
             <a:lvl1pPr marL="228600" indent="-228600">
               <a:lnSpc>
                 <a:spcPct val="110000"/>
@@ -1955,6 +1964,7 @@
                 <a:spcPts val="1200"/>
               </a:spcAft>
               <a:buChar char="•"/>
+              <a:defRPr/>
             </a:lvl1pPr>
             <a:lvl2pPr marL="533400" indent="-228600">
               <a:lnSpc>
@@ -1967,6 +1977,7 @@
                 <a:spcPts val="1200"/>
               </a:spcAft>
               <a:buChar char="•"/>
+              <a:defRPr/>
             </a:lvl2pPr>
             <a:lvl3pPr marL="838200" indent="-228600">
               <a:lnSpc>
@@ -1979,6 +1990,7 @@
                 <a:spcPts val="1200"/>
               </a:spcAft>
               <a:buChar char="•"/>
+              <a:defRPr/>
             </a:lvl3pPr>
             <a:lvl4pPr marL="1143000" indent="-228600">
               <a:lnSpc>
@@ -1991,6 +2003,7 @@
                 <a:spcPts val="1200"/>
               </a:spcAft>
               <a:buChar char="•"/>
+              <a:defRPr/>
             </a:lvl4pPr>
             <a:lvl5pPr marL="1447800" indent="-228600">
               <a:lnSpc>
@@ -2003,6 +2016,7 @@
                 <a:spcPts val="1200"/>
               </a:spcAft>
               <a:buChar char="•"/>
+              <a:defRPr/>
             </a:lvl5pPr>
             <a:lvl6pPr marL="1752600" indent="-228600">
               <a:lnSpc>
@@ -2015,6 +2029,7 @@
                 <a:spcPts val="1200"/>
               </a:spcAft>
               <a:buChar char="•"/>
+              <a:defRPr/>
             </a:lvl6pPr>
             <a:lvl7pPr marL="2057400" indent="-228600">
               <a:lnSpc>
@@ -2027,6 +2042,7 @@
                 <a:spcPts val="1200"/>
               </a:spcAft>
               <a:buChar char="•"/>
+              <a:defRPr/>
             </a:lvl7pPr>
             <a:lvl8pPr marL="2362200" indent="-228600">
               <a:lnSpc>
@@ -2039,6 +2055,7 @@
                 <a:spcPts val="1200"/>
               </a:spcAft>
               <a:buChar char="•"/>
+              <a:defRPr/>
             </a:lvl8pPr>
             <a:lvl9pPr marL="2667000" indent="-228600">
               <a:lnSpc>
@@ -2051,6 +2068,7 @@
                 <a:spcPts val="1200"/>
               </a:spcAft>
               <a:buChar char="•"/>
+              <a:defRPr/>
             </a:lvl9pPr>
           </a:lstStyle>
           <a:p xmlns:a="http://schemas.openxmlformats.org/drawingml/2006/main"/>
@@ -2091,16 +2109,6 @@
             <a:normAutofit/>
           </a:bodyPr>
           <a:lstStyle xmlns:a="http://schemas.openxmlformats.org/drawingml/2006/main">
-            <a:defPPr algn="l">
-              <a:defRPr sz="2100" b="0">
-                <a:solidFill>
-                  <a:schemeClr val="tx1"/>
-                </a:solidFill>
-                <a:latin typeface="+mn-lt"/>
-                <a:ea typeface="+mn-lt"/>
-                <a:cs typeface="+mn-lt"/>
-              </a:defRPr>
-            </a:defPPr>
             <a:lvl1pPr marL="228600" indent="-228600">
               <a:lnSpc>
                 <a:spcPct val="110000"/>
@@ -2112,6 +2120,7 @@
                 <a:spcPts val="1200"/>
               </a:spcAft>
               <a:buChar char="•"/>
+              <a:defRPr/>
             </a:lvl1pPr>
             <a:lvl2pPr marL="533400" indent="-228600">
               <a:lnSpc>
@@ -2124,6 +2133,7 @@
                 <a:spcPts val="1200"/>
               </a:spcAft>
               <a:buChar char="•"/>
+              <a:defRPr/>
             </a:lvl2pPr>
             <a:lvl3pPr marL="838200" indent="-228600">
               <a:lnSpc>
@@ -2136,6 +2146,7 @@
                 <a:spcPts val="1200"/>
               </a:spcAft>
               <a:buChar char="•"/>
+              <a:defRPr/>
             </a:lvl3pPr>
             <a:lvl4pPr marL="1143000" indent="-228600">
               <a:lnSpc>
@@ -2148,6 +2159,7 @@
                 <a:spcPts val="1200"/>
               </a:spcAft>
               <a:buChar char="•"/>
+              <a:defRPr/>
             </a:lvl4pPr>
             <a:lvl5pPr marL="1447800" indent="-228600">
               <a:lnSpc>
@@ -2160,6 +2172,7 @@
                 <a:spcPts val="1200"/>
               </a:spcAft>
               <a:buChar char="•"/>
+              <a:defRPr/>
             </a:lvl5pPr>
             <a:lvl6pPr marL="1752600" indent="-228600">
               <a:lnSpc>
@@ -2172,6 +2185,7 @@
                 <a:spcPts val="1200"/>
               </a:spcAft>
               <a:buChar char="•"/>
+              <a:defRPr/>
             </a:lvl6pPr>
             <a:lvl7pPr marL="2057400" indent="-228600">
               <a:lnSpc>
@@ -2184,6 +2198,7 @@
                 <a:spcPts val="1200"/>
               </a:spcAft>
               <a:buChar char="•"/>
+              <a:defRPr/>
             </a:lvl7pPr>
             <a:lvl8pPr marL="2362200" indent="-228600">
               <a:lnSpc>
@@ -2196,6 +2211,7 @@
                 <a:spcPts val="1200"/>
               </a:spcAft>
               <a:buChar char="•"/>
+              <a:defRPr/>
             </a:lvl8pPr>
             <a:lvl9pPr marL="2667000" indent="-228600">
               <a:lnSpc>
@@ -2208,6 +2224,7 @@
                 <a:spcPts val="1200"/>
               </a:spcAft>
               <a:buChar char="•"/>
+              <a:defRPr/>
             </a:lvl9pPr>
           </a:lstStyle>
           <a:p xmlns:a="http://schemas.openxmlformats.org/drawingml/2006/main"/>
@@ -2265,16 +2282,6 @@
             <a:normAutofit/>
           </a:bodyPr>
           <a:lstStyle xmlns:a="http://schemas.openxmlformats.org/drawingml/2006/main">
-            <a:defPPr algn="l">
-              <a:defRPr sz="3300" b="1">
-                <a:solidFill>
-                  <a:schemeClr val="tx1"/>
-                </a:solidFill>
-                <a:latin typeface="+mj-lt"/>
-                <a:ea typeface="+mj-lt"/>
-                <a:cs typeface="+mj-lt"/>
-              </a:defRPr>
-            </a:defPPr>
             <a:lvl1pPr marL="0" indent="0">
               <a:lnSpc>
                 <a:spcPct val="110000"/>
@@ -2286,6 +2293,7 @@
                 <a:spcPts val="0"/>
               </a:spcAft>
               <a:buNone/>
+              <a:defRPr/>
             </a:lvl1pPr>
             <a:lvl2pPr marL="0" indent="0">
               <a:lnSpc>
@@ -2298,6 +2306,7 @@
                 <a:spcPts val="0"/>
               </a:spcAft>
               <a:buNone/>
+              <a:defRPr/>
             </a:lvl2pPr>
             <a:lvl3pPr marL="0" indent="0">
               <a:lnSpc>
@@ -2310,6 +2319,7 @@
                 <a:spcPts val="0"/>
               </a:spcAft>
               <a:buNone/>
+              <a:defRPr/>
             </a:lvl3pPr>
             <a:lvl4pPr marL="0" indent="0">
               <a:lnSpc>
@@ -2322,6 +2332,7 @@
                 <a:spcPts val="0"/>
               </a:spcAft>
               <a:buNone/>
+              <a:defRPr/>
             </a:lvl4pPr>
             <a:lvl5pPr marL="0" indent="0">
               <a:lnSpc>
@@ -2334,6 +2345,7 @@
                 <a:spcPts val="0"/>
               </a:spcAft>
               <a:buNone/>
+              <a:defRPr/>
             </a:lvl5pPr>
             <a:lvl6pPr marL="0" indent="0">
               <a:lnSpc>
@@ -2346,6 +2358,7 @@
                 <a:spcPts val="0"/>
               </a:spcAft>
               <a:buNone/>
+              <a:defRPr/>
             </a:lvl6pPr>
             <a:lvl7pPr marL="0" indent="0">
               <a:lnSpc>
@@ -2358,6 +2371,7 @@
                 <a:spcPts val="0"/>
               </a:spcAft>
               <a:buNone/>
+              <a:defRPr/>
             </a:lvl7pPr>
             <a:lvl8pPr marL="0" indent="0">
               <a:lnSpc>
@@ -2370,6 +2384,7 @@
                 <a:spcPts val="0"/>
               </a:spcAft>
               <a:buNone/>
+              <a:defRPr/>
             </a:lvl8pPr>
             <a:lvl9pPr marL="0" indent="0">
               <a:lnSpc>
@@ -2382,6 +2397,7 @@
                 <a:spcPts val="0"/>
               </a:spcAft>
               <a:buNone/>
+              <a:defRPr/>
             </a:lvl9pPr>
           </a:lstStyle>
           <a:p xmlns:a="http://schemas.openxmlformats.org/drawingml/2006/main"/>
@@ -2422,16 +2438,6 @@
             <a:normAutofit/>
           </a:bodyPr>
           <a:lstStyle xmlns:a="http://schemas.openxmlformats.org/drawingml/2006/main">
-            <a:defPPr algn="l">
-              <a:defRPr sz="2250" b="0">
-                <a:solidFill>
-                  <a:schemeClr val="tx1"/>
-                </a:solidFill>
-                <a:latin typeface="+mn-lt"/>
-                <a:ea typeface="+mn-lt"/>
-                <a:cs typeface="+mn-lt"/>
-              </a:defRPr>
-            </a:defPPr>
             <a:lvl1pPr marL="228600" indent="-228600">
               <a:lnSpc>
                 <a:spcPct val="110000"/>
@@ -2443,6 +2449,7 @@
                 <a:spcPts val="1200"/>
               </a:spcAft>
               <a:buChar char="•"/>
+              <a:defRPr/>
             </a:lvl1pPr>
             <a:lvl2pPr marL="533400" indent="-228600">
               <a:lnSpc>
@@ -2455,6 +2462,7 @@
                 <a:spcPts val="1200"/>
               </a:spcAft>
               <a:buChar char="•"/>
+              <a:defRPr/>
             </a:lvl2pPr>
             <a:lvl3pPr marL="838200" indent="-228600">
               <a:lnSpc>
@@ -2467,6 +2475,7 @@
                 <a:spcPts val="1200"/>
               </a:spcAft>
               <a:buChar char="•"/>
+              <a:defRPr/>
             </a:lvl3pPr>
             <a:lvl4pPr marL="1143000" indent="-228600">
               <a:lnSpc>
@@ -2479,6 +2488,7 @@
                 <a:spcPts val="1200"/>
               </a:spcAft>
               <a:buChar char="•"/>
+              <a:defRPr/>
             </a:lvl4pPr>
             <a:lvl5pPr marL="1447800" indent="-228600">
               <a:lnSpc>
@@ -2491,6 +2501,7 @@
                 <a:spcPts val="1200"/>
               </a:spcAft>
               <a:buChar char="•"/>
+              <a:defRPr/>
             </a:lvl5pPr>
             <a:lvl6pPr marL="1752600" indent="-228600">
               <a:lnSpc>
@@ -2503,6 +2514,7 @@
                 <a:spcPts val="1200"/>
               </a:spcAft>
               <a:buChar char="•"/>
+              <a:defRPr/>
             </a:lvl6pPr>
             <a:lvl7pPr marL="2057400" indent="-228600">
               <a:lnSpc>
@@ -2515,6 +2527,7 @@
                 <a:spcPts val="1200"/>
               </a:spcAft>
               <a:buChar char="•"/>
+              <a:defRPr/>
             </a:lvl7pPr>
             <a:lvl8pPr marL="2362200" indent="-228600">
               <a:lnSpc>
@@ -2527,6 +2540,7 @@
                 <a:spcPts val="1200"/>
               </a:spcAft>
               <a:buChar char="•"/>
+              <a:defRPr/>
             </a:lvl8pPr>
             <a:lvl9pPr marL="2667000" indent="-228600">
               <a:lnSpc>
@@ -2539,6 +2553,7 @@
                 <a:spcPts val="1200"/>
               </a:spcAft>
               <a:buChar char="•"/>
+              <a:defRPr/>
             </a:lvl9pPr>
           </a:lstStyle>
           <a:p xmlns:a="http://schemas.openxmlformats.org/drawingml/2006/main"/>
@@ -2587,12 +2602,12 @@
   </p:cSld>
   <p:clrMap bg1="lt1" tx1="dk1" bg2="lt2" tx2="dk2" accent1="accent1" accent2="accent2" accent3="accent3" accent4="accent4" accent5="accent5" accent6="accent6" hlink="hlink" folHlink="folHlink"/>
   <p:sldLayoutIdLst>
-    <p:sldLayoutId xmlns:r="http://schemas.openxmlformats.org/officeDocument/2006/relationships" id="2147483649" r:id="Ra7f3f57d1e914c4d"/>
-    <p:sldLayoutId xmlns:r="http://schemas.openxmlformats.org/officeDocument/2006/relationships" id="2147483650" r:id="Rbb18ba390d14428b"/>
-    <p:sldLayoutId xmlns:r="http://schemas.openxmlformats.org/officeDocument/2006/relationships" id="2147483651" r:id="Rbb650267765e4fa0"/>
-    <p:sldLayoutId xmlns:r="http://schemas.openxmlformats.org/officeDocument/2006/relationships" id="2147483652" r:id="R6d6b3606454d49f6"/>
-    <p:sldLayoutId xmlns:r="http://schemas.openxmlformats.org/officeDocument/2006/relationships" id="2147483653" r:id="R76a5a9b93f5d4dec"/>
-    <p:sldLayoutId xmlns:r="http://schemas.openxmlformats.org/officeDocument/2006/relationships" id="2147483654" r:id="Rb78f406e066e4db0"/>
+    <p:sldLayoutId xmlns:r="http://schemas.openxmlformats.org/officeDocument/2006/relationships" id="2147483649" r:id="R383970adc61740f9"/>
+    <p:sldLayoutId xmlns:r="http://schemas.openxmlformats.org/officeDocument/2006/relationships" id="2147483650" r:id="R873109da2e584755"/>
+    <p:sldLayoutId xmlns:r="http://schemas.openxmlformats.org/officeDocument/2006/relationships" id="2147483651" r:id="R97aa8e7fc5ec4702"/>
+    <p:sldLayoutId xmlns:r="http://schemas.openxmlformats.org/officeDocument/2006/relationships" id="2147483652" r:id="R1dbc11b0f02c4d2c"/>
+    <p:sldLayoutId xmlns:r="http://schemas.openxmlformats.org/officeDocument/2006/relationships" id="2147483653" r:id="R55f9a4d254cf41b5"/>
+    <p:sldLayoutId xmlns:r="http://schemas.openxmlformats.org/officeDocument/2006/relationships" id="2147483654" r:id="Rb9323d4dba564f55"/>
   </p:sldLayoutIdLst>
   <p:txStyles>
     <p:titleStyle>
@@ -3168,20 +3183,10 @@
         </p:spPr>
         <p:txBody>
           <a:bodyPr xmlns:a="http://schemas.openxmlformats.org/drawingml/2006/main" anchor="ctr"/>
-          <a:lstStyle xmlns:a="http://schemas.openxmlformats.org/drawingml/2006/main">
-            <a:defPPr>
-              <a:defRPr sz="1650" b="1">
-                <a:solidFill>
-                  <a:srgbClr val="8FD0C8"/>
-                </a:solidFill>
-                <a:latin typeface="Aptos"/>
-                <a:ea typeface="Aptos"/>
-                <a:cs typeface="Aptos"/>
-              </a:defRPr>
-            </a:defPPr>
-          </a:lstStyle>
+          <a:lstStyle xmlns:a="http://schemas.openxmlformats.org/drawingml/2006/main"/>
           <a:p xmlns:a="http://schemas.openxmlformats.org/drawingml/2006/main">
             <a:pPr>
+              <a:buNone/>
               <a:defRPr sz="1650" b="1">
                 <a:solidFill>
                   <a:srgbClr val="8FD0C8"/>
@@ -3235,20 +3240,10 @@
         </p:spPr>
         <p:txBody>
           <a:bodyPr xmlns:a="http://schemas.openxmlformats.org/drawingml/2006/main" anchor="ctr"/>
-          <a:lstStyle xmlns:a="http://schemas.openxmlformats.org/drawingml/2006/main">
-            <a:defPPr>
-              <a:defRPr sz="4350" b="1">
-                <a:solidFill>
-                  <a:srgbClr val="FFFFFF"/>
-                </a:solidFill>
-                <a:latin typeface="Aptos"/>
-                <a:ea typeface="Aptos"/>
-                <a:cs typeface="Aptos"/>
-              </a:defRPr>
-            </a:defPPr>
-          </a:lstStyle>
+          <a:lstStyle xmlns:a="http://schemas.openxmlformats.org/drawingml/2006/main"/>
           <a:p xmlns:a="http://schemas.openxmlformats.org/drawingml/2006/main">
             <a:pPr>
+              <a:buNone/>
               <a:defRPr sz="4350" b="1">
                 <a:solidFill>
                   <a:srgbClr val="FFFFFF"/>
@@ -3272,6 +3267,7 @@
           </a:p>
           <a:p xmlns:a="http://schemas.openxmlformats.org/drawingml/2006/main">
             <a:pPr>
+              <a:buNone/>
               <a:defRPr sz="4350" b="1">
                 <a:solidFill>
                   <a:srgbClr val="FFFFFF"/>
@@ -3325,20 +3321,10 @@
         </p:spPr>
         <p:txBody>
           <a:bodyPr xmlns:a="http://schemas.openxmlformats.org/drawingml/2006/main" anchor="ctr"/>
-          <a:lstStyle xmlns:a="http://schemas.openxmlformats.org/drawingml/2006/main">
-            <a:defPPr>
-              <a:defRPr sz="1875" b="0">
-                <a:solidFill>
-                  <a:srgbClr val="D8E3E8"/>
-                </a:solidFill>
-                <a:latin typeface="Aptos"/>
-                <a:ea typeface="Aptos"/>
-                <a:cs typeface="Aptos"/>
-              </a:defRPr>
-            </a:defPPr>
-          </a:lstStyle>
+          <a:lstStyle xmlns:a="http://schemas.openxmlformats.org/drawingml/2006/main"/>
           <a:p xmlns:a="http://schemas.openxmlformats.org/drawingml/2006/main">
             <a:pPr>
+              <a:buNone/>
               <a:defRPr sz="1875" b="0">
                 <a:solidFill>
                   <a:srgbClr val="D8E3E8"/>
@@ -3423,20 +3409,10 @@
         </p:spPr>
         <p:txBody>
           <a:bodyPr xmlns:a="http://schemas.openxmlformats.org/drawingml/2006/main" anchor="ctr"/>
-          <a:lstStyle xmlns:a="http://schemas.openxmlformats.org/drawingml/2006/main">
-            <a:defPPr>
-              <a:defRPr sz="1500" b="0">
-                <a:solidFill>
-                  <a:srgbClr val="FFFFFF"/>
-                </a:solidFill>
-                <a:latin typeface="Aptos"/>
-                <a:ea typeface="Aptos"/>
-                <a:cs typeface="Aptos"/>
-              </a:defRPr>
-            </a:defPPr>
-          </a:lstStyle>
+          <a:lstStyle xmlns:a="http://schemas.openxmlformats.org/drawingml/2006/main"/>
           <a:p xmlns:a="http://schemas.openxmlformats.org/drawingml/2006/main">
             <a:pPr>
+              <a:buNone/>
               <a:defRPr sz="1500" b="0">
                 <a:solidFill>
                   <a:srgbClr val="FFFFFF"/>
@@ -3490,20 +3466,10 @@
         </p:spPr>
         <p:txBody>
           <a:bodyPr xmlns:a="http://schemas.openxmlformats.org/drawingml/2006/main" anchor="ctr"/>
-          <a:lstStyle xmlns:a="http://schemas.openxmlformats.org/drawingml/2006/main">
-            <a:defPPr>
-              <a:defRPr sz="1275" b="0">
-                <a:solidFill>
-                  <a:srgbClr val="C8D7DF"/>
-                </a:solidFill>
-                <a:latin typeface="Aptos"/>
-                <a:ea typeface="Aptos"/>
-                <a:cs typeface="Aptos"/>
-              </a:defRPr>
-            </a:defPPr>
-          </a:lstStyle>
+          <a:lstStyle xmlns:a="http://schemas.openxmlformats.org/drawingml/2006/main"/>
           <a:p xmlns:a="http://schemas.openxmlformats.org/drawingml/2006/main">
             <a:pPr>
+              <a:buNone/>
               <a:defRPr sz="1275" b="0">
                 <a:solidFill>
                   <a:srgbClr val="C8D7DF"/>
@@ -3557,20 +3523,10 @@
         </p:spPr>
         <p:txBody>
           <a:bodyPr xmlns:a="http://schemas.openxmlformats.org/drawingml/2006/main" anchor="ctr"/>
-          <a:lstStyle xmlns:a="http://schemas.openxmlformats.org/drawingml/2006/main">
-            <a:defPPr>
-              <a:defRPr sz="1125" b="0">
-                <a:solidFill>
-                  <a:srgbClr val="C8D7DF"/>
-                </a:solidFill>
-                <a:latin typeface="Aptos"/>
-                <a:ea typeface="Aptos"/>
-                <a:cs typeface="Aptos"/>
-              </a:defRPr>
-            </a:defPPr>
-          </a:lstStyle>
+          <a:lstStyle xmlns:a="http://schemas.openxmlformats.org/drawingml/2006/main"/>
           <a:p xmlns:a="http://schemas.openxmlformats.org/drawingml/2006/main">
             <a:pPr>
+              <a:buNone/>
               <a:defRPr sz="1125" b="0">
                 <a:solidFill>
                   <a:srgbClr val="C8D7DF"/>
@@ -3653,20 +3609,10 @@
         </p:spPr>
         <p:txBody>
           <a:bodyPr xmlns:a="http://schemas.openxmlformats.org/drawingml/2006/main" anchor="ctr"/>
-          <a:lstStyle xmlns:a="http://schemas.openxmlformats.org/drawingml/2006/main">
-            <a:defPPr>
-              <a:defRPr sz="2700" b="1">
-                <a:solidFill>
-                  <a:srgbClr val="15324B"/>
-                </a:solidFill>
-                <a:latin typeface="Aptos"/>
-                <a:ea typeface="Aptos"/>
-                <a:cs typeface="Aptos"/>
-              </a:defRPr>
-            </a:defPPr>
-          </a:lstStyle>
+          <a:lstStyle xmlns:a="http://schemas.openxmlformats.org/drawingml/2006/main"/>
           <a:p xmlns:a="http://schemas.openxmlformats.org/drawingml/2006/main">
             <a:pPr>
+              <a:buNone/>
               <a:defRPr sz="2700" b="1">
                 <a:solidFill>
                   <a:srgbClr val="15324B"/>
@@ -3751,20 +3697,10 @@
         </p:spPr>
         <p:txBody>
           <a:bodyPr xmlns:a="http://schemas.openxmlformats.org/drawingml/2006/main" anchor="ctr"/>
-          <a:lstStyle xmlns:a="http://schemas.openxmlformats.org/drawingml/2006/main">
-            <a:defPPr>
-              <a:defRPr sz="975" b="0">
-                <a:solidFill>
-                  <a:srgbClr val="526575"/>
-                </a:solidFill>
-                <a:latin typeface="Aptos"/>
-                <a:ea typeface="Aptos"/>
-                <a:cs typeface="Aptos"/>
-              </a:defRPr>
-            </a:defPPr>
-          </a:lstStyle>
+          <a:lstStyle xmlns:a="http://schemas.openxmlformats.org/drawingml/2006/main"/>
           <a:p xmlns:a="http://schemas.openxmlformats.org/drawingml/2006/main">
             <a:pPr>
+              <a:buNone/>
               <a:defRPr sz="975" b="0">
                 <a:solidFill>
                   <a:srgbClr val="526575"/>
@@ -3818,20 +3754,10 @@
         </p:spPr>
         <p:txBody>
           <a:bodyPr xmlns:a="http://schemas.openxmlformats.org/drawingml/2006/main" anchor="ctr"/>
-          <a:lstStyle xmlns:a="http://schemas.openxmlformats.org/drawingml/2006/main">
-            <a:defPPr>
-              <a:defRPr sz="2325" b="1">
-                <a:solidFill>
-                  <a:srgbClr val="1C2935"/>
-                </a:solidFill>
-                <a:latin typeface="Aptos"/>
-                <a:ea typeface="Aptos"/>
-                <a:cs typeface="Aptos"/>
-              </a:defRPr>
-            </a:defPPr>
-          </a:lstStyle>
+          <a:lstStyle xmlns:a="http://schemas.openxmlformats.org/drawingml/2006/main"/>
           <a:p xmlns:a="http://schemas.openxmlformats.org/drawingml/2006/main">
             <a:pPr>
+              <a:buNone/>
               <a:defRPr sz="2325" b="1">
                 <a:solidFill>
                   <a:srgbClr val="1C2935"/>
@@ -3885,20 +3811,10 @@
         </p:spPr>
         <p:txBody>
           <a:bodyPr xmlns:a="http://schemas.openxmlformats.org/drawingml/2006/main" anchor="ctr"/>
-          <a:lstStyle xmlns:a="http://schemas.openxmlformats.org/drawingml/2006/main">
-            <a:defPPr>
-              <a:defRPr sz="1650" b="0">
-                <a:solidFill>
-                  <a:srgbClr val="526575"/>
-                </a:solidFill>
-                <a:latin typeface="Aptos"/>
-                <a:ea typeface="Aptos"/>
-                <a:cs typeface="Aptos"/>
-              </a:defRPr>
-            </a:defPPr>
-          </a:lstStyle>
+          <a:lstStyle xmlns:a="http://schemas.openxmlformats.org/drawingml/2006/main"/>
           <a:p xmlns:a="http://schemas.openxmlformats.org/drawingml/2006/main">
             <a:pPr>
+              <a:buNone/>
               <a:defRPr sz="1650" b="0">
                 <a:solidFill>
                   <a:srgbClr val="526575"/>
@@ -3952,20 +3868,10 @@
         </p:spPr>
         <p:txBody>
           <a:bodyPr xmlns:a="http://schemas.openxmlformats.org/drawingml/2006/main" anchor="ctr"/>
-          <a:lstStyle xmlns:a="http://schemas.openxmlformats.org/drawingml/2006/main">
-            <a:defPPr>
-              <a:defRPr sz="3900" b="1">
-                <a:solidFill>
-                  <a:srgbClr val="15324B"/>
-                </a:solidFill>
-                <a:latin typeface="Aptos"/>
-                <a:ea typeface="Aptos"/>
-                <a:cs typeface="Aptos"/>
-              </a:defRPr>
-            </a:defPPr>
-          </a:lstStyle>
+          <a:lstStyle xmlns:a="http://schemas.openxmlformats.org/drawingml/2006/main"/>
           <a:p xmlns:a="http://schemas.openxmlformats.org/drawingml/2006/main">
             <a:pPr>
+              <a:buNone/>
               <a:defRPr sz="3900" b="1">
                 <a:solidFill>
                   <a:srgbClr val="15324B"/>
@@ -4019,20 +3925,10 @@
         </p:spPr>
         <p:txBody>
           <a:bodyPr xmlns:a="http://schemas.openxmlformats.org/drawingml/2006/main" anchor="ctr"/>
-          <a:lstStyle xmlns:a="http://schemas.openxmlformats.org/drawingml/2006/main">
-            <a:defPPr>
-              <a:defRPr sz="1500" b="0">
-                <a:solidFill>
-                  <a:srgbClr val="526575"/>
-                </a:solidFill>
-                <a:latin typeface="Aptos"/>
-                <a:ea typeface="Aptos"/>
-                <a:cs typeface="Aptos"/>
-              </a:defRPr>
-            </a:defPPr>
-          </a:lstStyle>
+          <a:lstStyle xmlns:a="http://schemas.openxmlformats.org/drawingml/2006/main"/>
           <a:p xmlns:a="http://schemas.openxmlformats.org/drawingml/2006/main">
             <a:pPr>
+              <a:buNone/>
               <a:defRPr sz="1500" b="0">
                 <a:solidFill>
                   <a:srgbClr val="526575"/>
@@ -4086,20 +3982,10 @@
         </p:spPr>
         <p:txBody>
           <a:bodyPr xmlns:a="http://schemas.openxmlformats.org/drawingml/2006/main" anchor="ctr"/>
-          <a:lstStyle xmlns:a="http://schemas.openxmlformats.org/drawingml/2006/main">
-            <a:defPPr>
-              <a:defRPr sz="3900" b="1">
-                <a:solidFill>
-                  <a:srgbClr val="157A78"/>
-                </a:solidFill>
-                <a:latin typeface="Aptos"/>
-                <a:ea typeface="Aptos"/>
-                <a:cs typeface="Aptos"/>
-              </a:defRPr>
-            </a:defPPr>
-          </a:lstStyle>
+          <a:lstStyle xmlns:a="http://schemas.openxmlformats.org/drawingml/2006/main"/>
           <a:p xmlns:a="http://schemas.openxmlformats.org/drawingml/2006/main">
             <a:pPr>
+              <a:buNone/>
               <a:defRPr sz="3900" b="1">
                 <a:solidFill>
                   <a:srgbClr val="157A78"/>
@@ -4153,20 +4039,10 @@
         </p:spPr>
         <p:txBody>
           <a:bodyPr xmlns:a="http://schemas.openxmlformats.org/drawingml/2006/main" anchor="ctr"/>
-          <a:lstStyle xmlns:a="http://schemas.openxmlformats.org/drawingml/2006/main">
-            <a:defPPr>
-              <a:defRPr sz="1500" b="0">
-                <a:solidFill>
-                  <a:srgbClr val="526575"/>
-                </a:solidFill>
-                <a:latin typeface="Aptos"/>
-                <a:ea typeface="Aptos"/>
-                <a:cs typeface="Aptos"/>
-              </a:defRPr>
-            </a:defPPr>
-          </a:lstStyle>
+          <a:lstStyle xmlns:a="http://schemas.openxmlformats.org/drawingml/2006/main"/>
           <a:p xmlns:a="http://schemas.openxmlformats.org/drawingml/2006/main">
             <a:pPr>
+              <a:buNone/>
               <a:defRPr sz="1500" b="0">
                 <a:solidFill>
                   <a:srgbClr val="526575"/>
@@ -4220,20 +4096,10 @@
         </p:spPr>
         <p:txBody>
           <a:bodyPr xmlns:a="http://schemas.openxmlformats.org/drawingml/2006/main" anchor="ctr"/>
-          <a:lstStyle xmlns:a="http://schemas.openxmlformats.org/drawingml/2006/main">
-            <a:defPPr>
-              <a:defRPr sz="3900" b="1">
-                <a:solidFill>
-                  <a:srgbClr val="15324B"/>
-                </a:solidFill>
-                <a:latin typeface="Aptos"/>
-                <a:ea typeface="Aptos"/>
-                <a:cs typeface="Aptos"/>
-              </a:defRPr>
-            </a:defPPr>
-          </a:lstStyle>
+          <a:lstStyle xmlns:a="http://schemas.openxmlformats.org/drawingml/2006/main"/>
           <a:p xmlns:a="http://schemas.openxmlformats.org/drawingml/2006/main">
             <a:pPr>
+              <a:buNone/>
               <a:defRPr sz="3900" b="1">
                 <a:solidFill>
                   <a:srgbClr val="15324B"/>
@@ -4287,20 +4153,10 @@
         </p:spPr>
         <p:txBody>
           <a:bodyPr xmlns:a="http://schemas.openxmlformats.org/drawingml/2006/main" anchor="ctr"/>
-          <a:lstStyle xmlns:a="http://schemas.openxmlformats.org/drawingml/2006/main">
-            <a:defPPr>
-              <a:defRPr sz="1500" b="0">
-                <a:solidFill>
-                  <a:srgbClr val="526575"/>
-                </a:solidFill>
-                <a:latin typeface="Aptos"/>
-                <a:ea typeface="Aptos"/>
-                <a:cs typeface="Aptos"/>
-              </a:defRPr>
-            </a:defPPr>
-          </a:lstStyle>
+          <a:lstStyle xmlns:a="http://schemas.openxmlformats.org/drawingml/2006/main"/>
           <a:p xmlns:a="http://schemas.openxmlformats.org/drawingml/2006/main">
             <a:pPr>
+              <a:buNone/>
               <a:defRPr sz="1500" b="0">
                 <a:solidFill>
                   <a:srgbClr val="526575"/>
@@ -4354,20 +4210,10 @@
         </p:spPr>
         <p:txBody>
           <a:bodyPr xmlns:a="http://schemas.openxmlformats.org/drawingml/2006/main" anchor="ctr"/>
-          <a:lstStyle xmlns:a="http://schemas.openxmlformats.org/drawingml/2006/main">
-            <a:defPPr>
-              <a:defRPr sz="1650" b="1">
-                <a:solidFill>
-                  <a:srgbClr val="157A78"/>
-                </a:solidFill>
-                <a:latin typeface="Aptos"/>
-                <a:ea typeface="Aptos"/>
-                <a:cs typeface="Aptos"/>
-              </a:defRPr>
-            </a:defPPr>
-          </a:lstStyle>
+          <a:lstStyle xmlns:a="http://schemas.openxmlformats.org/drawingml/2006/main"/>
           <a:p xmlns:a="http://schemas.openxmlformats.org/drawingml/2006/main">
             <a:pPr>
+              <a:buNone/>
               <a:defRPr sz="1650" b="1">
                 <a:solidFill>
                   <a:srgbClr val="157A78"/>
@@ -4421,20 +4267,10 @@
         </p:spPr>
         <p:txBody>
           <a:bodyPr xmlns:a="http://schemas.openxmlformats.org/drawingml/2006/main" anchor="ctr"/>
-          <a:lstStyle xmlns:a="http://schemas.openxmlformats.org/drawingml/2006/main">
-            <a:defPPr>
-              <a:defRPr sz="1575" b="0">
-                <a:solidFill>
-                  <a:srgbClr val="1C2935"/>
-                </a:solidFill>
-                <a:latin typeface="Aptos"/>
-                <a:ea typeface="Aptos"/>
-                <a:cs typeface="Aptos"/>
-              </a:defRPr>
-            </a:defPPr>
-          </a:lstStyle>
+          <a:lstStyle xmlns:a="http://schemas.openxmlformats.org/drawingml/2006/main"/>
           <a:p xmlns:a="http://schemas.openxmlformats.org/drawingml/2006/main">
             <a:pPr>
+              <a:buNone/>
               <a:defRPr sz="1575" b="0">
                 <a:solidFill>
                   <a:srgbClr val="1C2935"/>
@@ -4458,6 +4294,7 @@
           </a:p>
           <a:p xmlns:a="http://schemas.openxmlformats.org/drawingml/2006/main">
             <a:pPr>
+              <a:buNone/>
               <a:defRPr sz="1575" b="0">
                 <a:solidFill>
                   <a:srgbClr val="1C2935"/>
@@ -4481,6 +4318,7 @@
           </a:p>
           <a:p xmlns:a="http://schemas.openxmlformats.org/drawingml/2006/main">
             <a:pPr>
+              <a:buNone/>
               <a:defRPr sz="1575" b="0">
                 <a:solidFill>
                   <a:srgbClr val="1C2935"/>
@@ -4563,20 +4401,10 @@
         </p:spPr>
         <p:txBody>
           <a:bodyPr xmlns:a="http://schemas.openxmlformats.org/drawingml/2006/main" anchor="ctr"/>
-          <a:lstStyle xmlns:a="http://schemas.openxmlformats.org/drawingml/2006/main">
-            <a:defPPr>
-              <a:defRPr sz="2700" b="1">
-                <a:solidFill>
-                  <a:srgbClr val="15324B"/>
-                </a:solidFill>
-                <a:latin typeface="Aptos"/>
-                <a:ea typeface="Aptos"/>
-                <a:cs typeface="Aptos"/>
-              </a:defRPr>
-            </a:defPPr>
-          </a:lstStyle>
+          <a:lstStyle xmlns:a="http://schemas.openxmlformats.org/drawingml/2006/main"/>
           <a:p xmlns:a="http://schemas.openxmlformats.org/drawingml/2006/main">
             <a:pPr>
+              <a:buNone/>
               <a:defRPr sz="2700" b="1">
                 <a:solidFill>
                   <a:srgbClr val="15324B"/>
@@ -4661,20 +4489,10 @@
         </p:spPr>
         <p:txBody>
           <a:bodyPr xmlns:a="http://schemas.openxmlformats.org/drawingml/2006/main" anchor="ctr"/>
-          <a:lstStyle xmlns:a="http://schemas.openxmlformats.org/drawingml/2006/main">
-            <a:defPPr>
-              <a:defRPr sz="975" b="0">
-                <a:solidFill>
-                  <a:srgbClr val="526575"/>
-                </a:solidFill>
-                <a:latin typeface="Aptos"/>
-                <a:ea typeface="Aptos"/>
-                <a:cs typeface="Aptos"/>
-              </a:defRPr>
-            </a:defPPr>
-          </a:lstStyle>
+          <a:lstStyle xmlns:a="http://schemas.openxmlformats.org/drawingml/2006/main"/>
           <a:p xmlns:a="http://schemas.openxmlformats.org/drawingml/2006/main">
             <a:pPr>
+              <a:buNone/>
               <a:defRPr sz="975" b="0">
                 <a:solidFill>
                   <a:srgbClr val="526575"/>
@@ -4728,20 +4546,10 @@
         </p:spPr>
         <p:txBody>
           <a:bodyPr xmlns:a="http://schemas.openxmlformats.org/drawingml/2006/main" anchor="ctr"/>
-          <a:lstStyle xmlns:a="http://schemas.openxmlformats.org/drawingml/2006/main">
-            <a:defPPr>
-              <a:defRPr sz="2550" b="1">
-                <a:solidFill>
-                  <a:srgbClr val="157A78"/>
-                </a:solidFill>
-                <a:latin typeface="Aptos"/>
-                <a:ea typeface="Aptos"/>
-                <a:cs typeface="Aptos"/>
-              </a:defRPr>
-            </a:defPPr>
-          </a:lstStyle>
+          <a:lstStyle xmlns:a="http://schemas.openxmlformats.org/drawingml/2006/main"/>
           <a:p xmlns:a="http://schemas.openxmlformats.org/drawingml/2006/main">
             <a:pPr>
+              <a:buNone/>
               <a:defRPr sz="2550" b="1">
                 <a:solidFill>
                   <a:srgbClr val="157A78"/>
@@ -4795,20 +4603,10 @@
         </p:spPr>
         <p:txBody>
           <a:bodyPr xmlns:a="http://schemas.openxmlformats.org/drawingml/2006/main" anchor="ctr"/>
-          <a:lstStyle xmlns:a="http://schemas.openxmlformats.org/drawingml/2006/main">
-            <a:defPPr>
-              <a:defRPr sz="1875" b="1">
-                <a:solidFill>
-                  <a:srgbClr val="15324B"/>
-                </a:solidFill>
-                <a:latin typeface="Aptos"/>
-                <a:ea typeface="Aptos"/>
-                <a:cs typeface="Aptos"/>
-              </a:defRPr>
-            </a:defPPr>
-          </a:lstStyle>
+          <a:lstStyle xmlns:a="http://schemas.openxmlformats.org/drawingml/2006/main"/>
           <a:p xmlns:a="http://schemas.openxmlformats.org/drawingml/2006/main">
             <a:pPr>
+              <a:buNone/>
               <a:defRPr sz="1875" b="1">
                 <a:solidFill>
                   <a:srgbClr val="15324B"/>
@@ -4862,20 +4660,10 @@
         </p:spPr>
         <p:txBody>
           <a:bodyPr xmlns:a="http://schemas.openxmlformats.org/drawingml/2006/main" anchor="ctr"/>
-          <a:lstStyle xmlns:a="http://schemas.openxmlformats.org/drawingml/2006/main">
-            <a:defPPr>
-              <a:defRPr sz="1425" b="0">
-                <a:solidFill>
-                  <a:srgbClr val="526575"/>
-                </a:solidFill>
-                <a:latin typeface="Aptos"/>
-                <a:ea typeface="Aptos"/>
-                <a:cs typeface="Aptos"/>
-              </a:defRPr>
-            </a:defPPr>
-          </a:lstStyle>
+          <a:lstStyle xmlns:a="http://schemas.openxmlformats.org/drawingml/2006/main"/>
           <a:p xmlns:a="http://schemas.openxmlformats.org/drawingml/2006/main">
             <a:pPr>
+              <a:buNone/>
               <a:defRPr sz="1425" b="0">
                 <a:solidFill>
                   <a:srgbClr val="526575"/>
@@ -4960,20 +4748,10 @@
         </p:spPr>
         <p:txBody>
           <a:bodyPr xmlns:a="http://schemas.openxmlformats.org/drawingml/2006/main" anchor="ctr"/>
-          <a:lstStyle xmlns:a="http://schemas.openxmlformats.org/drawingml/2006/main">
-            <a:defPPr>
-              <a:defRPr sz="2550" b="1">
-                <a:solidFill>
-                  <a:srgbClr val="157A78"/>
-                </a:solidFill>
-                <a:latin typeface="Aptos"/>
-                <a:ea typeface="Aptos"/>
-                <a:cs typeface="Aptos"/>
-              </a:defRPr>
-            </a:defPPr>
-          </a:lstStyle>
+          <a:lstStyle xmlns:a="http://schemas.openxmlformats.org/drawingml/2006/main"/>
           <a:p xmlns:a="http://schemas.openxmlformats.org/drawingml/2006/main">
             <a:pPr>
+              <a:buNone/>
               <a:defRPr sz="2550" b="1">
                 <a:solidFill>
                   <a:srgbClr val="157A78"/>
@@ -5027,20 +4805,10 @@
         </p:spPr>
         <p:txBody>
           <a:bodyPr xmlns:a="http://schemas.openxmlformats.org/drawingml/2006/main" anchor="ctr"/>
-          <a:lstStyle xmlns:a="http://schemas.openxmlformats.org/drawingml/2006/main">
-            <a:defPPr>
-              <a:defRPr sz="1875" b="1">
-                <a:solidFill>
-                  <a:srgbClr val="15324B"/>
-                </a:solidFill>
-                <a:latin typeface="Aptos"/>
-                <a:ea typeface="Aptos"/>
-                <a:cs typeface="Aptos"/>
-              </a:defRPr>
-            </a:defPPr>
-          </a:lstStyle>
+          <a:lstStyle xmlns:a="http://schemas.openxmlformats.org/drawingml/2006/main"/>
           <a:p xmlns:a="http://schemas.openxmlformats.org/drawingml/2006/main">
             <a:pPr>
+              <a:buNone/>
               <a:defRPr sz="1875" b="1">
                 <a:solidFill>
                   <a:srgbClr val="15324B"/>
@@ -5094,20 +4862,10 @@
         </p:spPr>
         <p:txBody>
           <a:bodyPr xmlns:a="http://schemas.openxmlformats.org/drawingml/2006/main" anchor="ctr"/>
-          <a:lstStyle xmlns:a="http://schemas.openxmlformats.org/drawingml/2006/main">
-            <a:defPPr>
-              <a:defRPr sz="1425" b="0">
-                <a:solidFill>
-                  <a:srgbClr val="526575"/>
-                </a:solidFill>
-                <a:latin typeface="Aptos"/>
-                <a:ea typeface="Aptos"/>
-                <a:cs typeface="Aptos"/>
-              </a:defRPr>
-            </a:defPPr>
-          </a:lstStyle>
+          <a:lstStyle xmlns:a="http://schemas.openxmlformats.org/drawingml/2006/main"/>
           <a:p xmlns:a="http://schemas.openxmlformats.org/drawingml/2006/main">
             <a:pPr>
+              <a:buNone/>
               <a:defRPr sz="1425" b="0">
                 <a:solidFill>
                   <a:srgbClr val="526575"/>
@@ -5192,20 +4950,10 @@
         </p:spPr>
         <p:txBody>
           <a:bodyPr xmlns:a="http://schemas.openxmlformats.org/drawingml/2006/main" anchor="ctr"/>
-          <a:lstStyle xmlns:a="http://schemas.openxmlformats.org/drawingml/2006/main">
-            <a:defPPr>
-              <a:defRPr sz="2550" b="1">
-                <a:solidFill>
-                  <a:srgbClr val="157A78"/>
-                </a:solidFill>
-                <a:latin typeface="Aptos"/>
-                <a:ea typeface="Aptos"/>
-                <a:cs typeface="Aptos"/>
-              </a:defRPr>
-            </a:defPPr>
-          </a:lstStyle>
+          <a:lstStyle xmlns:a="http://schemas.openxmlformats.org/drawingml/2006/main"/>
           <a:p xmlns:a="http://schemas.openxmlformats.org/drawingml/2006/main">
             <a:pPr>
+              <a:buNone/>
               <a:defRPr sz="2550" b="1">
                 <a:solidFill>
                   <a:srgbClr val="157A78"/>
@@ -5259,20 +5007,10 @@
         </p:spPr>
         <p:txBody>
           <a:bodyPr xmlns:a="http://schemas.openxmlformats.org/drawingml/2006/main" anchor="ctr"/>
-          <a:lstStyle xmlns:a="http://schemas.openxmlformats.org/drawingml/2006/main">
-            <a:defPPr>
-              <a:defRPr sz="1875" b="1">
-                <a:solidFill>
-                  <a:srgbClr val="15324B"/>
-                </a:solidFill>
-                <a:latin typeface="Aptos"/>
-                <a:ea typeface="Aptos"/>
-                <a:cs typeface="Aptos"/>
-              </a:defRPr>
-            </a:defPPr>
-          </a:lstStyle>
+          <a:lstStyle xmlns:a="http://schemas.openxmlformats.org/drawingml/2006/main"/>
           <a:p xmlns:a="http://schemas.openxmlformats.org/drawingml/2006/main">
             <a:pPr>
+              <a:buNone/>
               <a:defRPr sz="1875" b="1">
                 <a:solidFill>
                   <a:srgbClr val="15324B"/>
@@ -5326,20 +5064,10 @@
         </p:spPr>
         <p:txBody>
           <a:bodyPr xmlns:a="http://schemas.openxmlformats.org/drawingml/2006/main" anchor="ctr"/>
-          <a:lstStyle xmlns:a="http://schemas.openxmlformats.org/drawingml/2006/main">
-            <a:defPPr>
-              <a:defRPr sz="1425" b="0">
-                <a:solidFill>
-                  <a:srgbClr val="526575"/>
-                </a:solidFill>
-                <a:latin typeface="Aptos"/>
-                <a:ea typeface="Aptos"/>
-                <a:cs typeface="Aptos"/>
-              </a:defRPr>
-            </a:defPPr>
-          </a:lstStyle>
+          <a:lstStyle xmlns:a="http://schemas.openxmlformats.org/drawingml/2006/main"/>
           <a:p xmlns:a="http://schemas.openxmlformats.org/drawingml/2006/main">
             <a:pPr>
+              <a:buNone/>
               <a:defRPr sz="1425" b="0">
                 <a:solidFill>
                   <a:srgbClr val="526575"/>
@@ -5424,20 +5152,10 @@
         </p:spPr>
         <p:txBody>
           <a:bodyPr xmlns:a="http://schemas.openxmlformats.org/drawingml/2006/main" anchor="ctr"/>
-          <a:lstStyle xmlns:a="http://schemas.openxmlformats.org/drawingml/2006/main">
-            <a:defPPr>
-              <a:defRPr sz="2550" b="1">
-                <a:solidFill>
-                  <a:srgbClr val="157A78"/>
-                </a:solidFill>
-                <a:latin typeface="Aptos"/>
-                <a:ea typeface="Aptos"/>
-                <a:cs typeface="Aptos"/>
-              </a:defRPr>
-            </a:defPPr>
-          </a:lstStyle>
+          <a:lstStyle xmlns:a="http://schemas.openxmlformats.org/drawingml/2006/main"/>
           <a:p xmlns:a="http://schemas.openxmlformats.org/drawingml/2006/main">
             <a:pPr>
+              <a:buNone/>
               <a:defRPr sz="2550" b="1">
                 <a:solidFill>
                   <a:srgbClr val="157A78"/>
@@ -5491,20 +5209,10 @@
         </p:spPr>
         <p:txBody>
           <a:bodyPr xmlns:a="http://schemas.openxmlformats.org/drawingml/2006/main" anchor="ctr"/>
-          <a:lstStyle xmlns:a="http://schemas.openxmlformats.org/drawingml/2006/main">
-            <a:defPPr>
-              <a:defRPr sz="1875" b="1">
-                <a:solidFill>
-                  <a:srgbClr val="15324B"/>
-                </a:solidFill>
-                <a:latin typeface="Aptos"/>
-                <a:ea typeface="Aptos"/>
-                <a:cs typeface="Aptos"/>
-              </a:defRPr>
-            </a:defPPr>
-          </a:lstStyle>
+          <a:lstStyle xmlns:a="http://schemas.openxmlformats.org/drawingml/2006/main"/>
           <a:p xmlns:a="http://schemas.openxmlformats.org/drawingml/2006/main">
             <a:pPr>
+              <a:buNone/>
               <a:defRPr sz="1875" b="1">
                 <a:solidFill>
                   <a:srgbClr val="15324B"/>
@@ -5558,20 +5266,10 @@
         </p:spPr>
         <p:txBody>
           <a:bodyPr xmlns:a="http://schemas.openxmlformats.org/drawingml/2006/main" anchor="ctr"/>
-          <a:lstStyle xmlns:a="http://schemas.openxmlformats.org/drawingml/2006/main">
-            <a:defPPr>
-              <a:defRPr sz="1425" b="0">
-                <a:solidFill>
-                  <a:srgbClr val="526575"/>
-                </a:solidFill>
-                <a:latin typeface="Aptos"/>
-                <a:ea typeface="Aptos"/>
-                <a:cs typeface="Aptos"/>
-              </a:defRPr>
-            </a:defPPr>
-          </a:lstStyle>
+          <a:lstStyle xmlns:a="http://schemas.openxmlformats.org/drawingml/2006/main"/>
           <a:p xmlns:a="http://schemas.openxmlformats.org/drawingml/2006/main">
             <a:pPr>
+              <a:buNone/>
               <a:defRPr sz="1425" b="0">
                 <a:solidFill>
                   <a:srgbClr val="526575"/>
@@ -5625,20 +5323,10 @@
         </p:spPr>
         <p:txBody>
           <a:bodyPr xmlns:a="http://schemas.openxmlformats.org/drawingml/2006/main" anchor="ctr"/>
-          <a:lstStyle xmlns:a="http://schemas.openxmlformats.org/drawingml/2006/main">
-            <a:defPPr>
-              <a:defRPr sz="1200" b="0">
-                <a:solidFill>
-                  <a:srgbClr val="AA5E57"/>
-                </a:solidFill>
-                <a:latin typeface="Aptos"/>
-                <a:ea typeface="Aptos"/>
-                <a:cs typeface="Aptos"/>
-              </a:defRPr>
-            </a:defPPr>
-          </a:lstStyle>
+          <a:lstStyle xmlns:a="http://schemas.openxmlformats.org/drawingml/2006/main"/>
           <a:p xmlns:a="http://schemas.openxmlformats.org/drawingml/2006/main">
             <a:pPr>
+              <a:buNone/>
               <a:defRPr sz="1200" b="0">
                 <a:solidFill>
                   <a:srgbClr val="AA5E57"/>
@@ -5721,20 +5409,10 @@
         </p:spPr>
         <p:txBody>
           <a:bodyPr xmlns:a="http://schemas.openxmlformats.org/drawingml/2006/main" anchor="ctr"/>
-          <a:lstStyle xmlns:a="http://schemas.openxmlformats.org/drawingml/2006/main">
-            <a:defPPr>
-              <a:defRPr sz="2700" b="1">
-                <a:solidFill>
-                  <a:srgbClr val="15324B"/>
-                </a:solidFill>
-                <a:latin typeface="Aptos"/>
-                <a:ea typeface="Aptos"/>
-                <a:cs typeface="Aptos"/>
-              </a:defRPr>
-            </a:defPPr>
-          </a:lstStyle>
+          <a:lstStyle xmlns:a="http://schemas.openxmlformats.org/drawingml/2006/main"/>
           <a:p xmlns:a="http://schemas.openxmlformats.org/drawingml/2006/main">
             <a:pPr>
+              <a:buNone/>
               <a:defRPr sz="2700" b="1">
                 <a:solidFill>
                   <a:srgbClr val="15324B"/>
@@ -5819,20 +5497,10 @@
         </p:spPr>
         <p:txBody>
           <a:bodyPr xmlns:a="http://schemas.openxmlformats.org/drawingml/2006/main" anchor="ctr"/>
-          <a:lstStyle xmlns:a="http://schemas.openxmlformats.org/drawingml/2006/main">
-            <a:defPPr>
-              <a:defRPr sz="975" b="0">
-                <a:solidFill>
-                  <a:srgbClr val="526575"/>
-                </a:solidFill>
-                <a:latin typeface="Aptos"/>
-                <a:ea typeface="Aptos"/>
-                <a:cs typeface="Aptos"/>
-              </a:defRPr>
-            </a:defPPr>
-          </a:lstStyle>
+          <a:lstStyle xmlns:a="http://schemas.openxmlformats.org/drawingml/2006/main"/>
           <a:p xmlns:a="http://schemas.openxmlformats.org/drawingml/2006/main">
             <a:pPr>
+              <a:buNone/>
               <a:defRPr sz="975" b="0">
                 <a:solidFill>
                   <a:srgbClr val="526575"/>
@@ -5886,20 +5554,10 @@
         </p:spPr>
         <p:txBody>
           <a:bodyPr xmlns:a="http://schemas.openxmlformats.org/drawingml/2006/main" anchor="ctr"/>
-          <a:lstStyle xmlns:a="http://schemas.openxmlformats.org/drawingml/2006/main">
-            <a:defPPr>
-              <a:defRPr sz="1800" b="1">
-                <a:solidFill>
-                  <a:srgbClr val="1C2935"/>
-                </a:solidFill>
-                <a:latin typeface="Aptos"/>
-                <a:ea typeface="Aptos"/>
-                <a:cs typeface="Aptos"/>
-              </a:defRPr>
-            </a:defPPr>
-          </a:lstStyle>
+          <a:lstStyle xmlns:a="http://schemas.openxmlformats.org/drawingml/2006/main"/>
           <a:p xmlns:a="http://schemas.openxmlformats.org/drawingml/2006/main">
             <a:pPr>
+              <a:buNone/>
               <a:defRPr sz="1800" b="1">
                 <a:solidFill>
                   <a:srgbClr val="1C2935"/>
@@ -5925,13 +5583,7 @@
       </p:sp>
       <p:graphicFrame>
         <p:nvGraphicFramePr>
-          <p:cNvPr id="5" name="">
-            <a:extLst xmlns:a="http://schemas.openxmlformats.org/drawingml/2006/main">
-              <a:ext uri="{FF2B5EF4-FFF2-40B4-BE49-F238E27FC236}">
-                <a16:creationId xmlns:a16="http://schemas.microsoft.com/office/drawing/2014/main" id="{4D7E7643-7F5B-430B-921E-1FA86ED3A430}"/>
-              </a:ext>
-            </a:extLst>
-          </p:cNvPr>
+          <p:cNvPr id="14" name=""/>
           <p:cNvGraphicFramePr/>
           <p:nvPr/>
         </p:nvGraphicFramePr>
@@ -6513,20 +6165,10 @@
         </p:spPr>
         <p:txBody>
           <a:bodyPr xmlns:a="http://schemas.openxmlformats.org/drawingml/2006/main" anchor="ctr"/>
-          <a:lstStyle xmlns:a="http://schemas.openxmlformats.org/drawingml/2006/main">
-            <a:defPPr>
-              <a:defRPr sz="1275" b="0">
-                <a:solidFill>
-                  <a:srgbClr val="526575"/>
-                </a:solidFill>
-                <a:latin typeface="Aptos"/>
-                <a:ea typeface="Aptos"/>
-                <a:cs typeface="Aptos"/>
-              </a:defRPr>
-            </a:defPPr>
-          </a:lstStyle>
+          <a:lstStyle xmlns:a="http://schemas.openxmlformats.org/drawingml/2006/main"/>
           <a:p xmlns:a="http://schemas.openxmlformats.org/drawingml/2006/main">
             <a:pPr>
+              <a:buNone/>
               <a:defRPr sz="1275" b="0">
                 <a:solidFill>
                   <a:srgbClr val="526575"/>
@@ -6580,20 +6222,10 @@
         </p:spPr>
         <p:txBody>
           <a:bodyPr xmlns:a="http://schemas.openxmlformats.org/drawingml/2006/main" anchor="ctr"/>
-          <a:lstStyle xmlns:a="http://schemas.openxmlformats.org/drawingml/2006/main">
-            <a:defPPr>
-              <a:defRPr sz="1425" b="1">
-                <a:solidFill>
-                  <a:srgbClr val="157A78"/>
-                </a:solidFill>
-                <a:latin typeface="Aptos"/>
-                <a:ea typeface="Aptos"/>
-                <a:cs typeface="Aptos"/>
-              </a:defRPr>
-            </a:defPPr>
-          </a:lstStyle>
+          <a:lstStyle xmlns:a="http://schemas.openxmlformats.org/drawingml/2006/main"/>
           <a:p xmlns:a="http://schemas.openxmlformats.org/drawingml/2006/main">
             <a:pPr>
+              <a:buNone/>
               <a:defRPr sz="1425" b="1">
                 <a:solidFill>
                   <a:srgbClr val="157A78"/>
@@ -6676,20 +6308,10 @@
         </p:spPr>
         <p:txBody>
           <a:bodyPr xmlns:a="http://schemas.openxmlformats.org/drawingml/2006/main" anchor="ctr"/>
-          <a:lstStyle xmlns:a="http://schemas.openxmlformats.org/drawingml/2006/main">
-            <a:defPPr>
-              <a:defRPr sz="2700" b="1">
-                <a:solidFill>
-                  <a:srgbClr val="15324B"/>
-                </a:solidFill>
-                <a:latin typeface="Aptos"/>
-                <a:ea typeface="Aptos"/>
-                <a:cs typeface="Aptos"/>
-              </a:defRPr>
-            </a:defPPr>
-          </a:lstStyle>
+          <a:lstStyle xmlns:a="http://schemas.openxmlformats.org/drawingml/2006/main"/>
           <a:p xmlns:a="http://schemas.openxmlformats.org/drawingml/2006/main">
             <a:pPr>
+              <a:buNone/>
               <a:defRPr sz="2700" b="1">
                 <a:solidFill>
                   <a:srgbClr val="15324B"/>
@@ -6774,20 +6396,10 @@
         </p:spPr>
         <p:txBody>
           <a:bodyPr xmlns:a="http://schemas.openxmlformats.org/drawingml/2006/main" anchor="ctr"/>
-          <a:lstStyle xmlns:a="http://schemas.openxmlformats.org/drawingml/2006/main">
-            <a:defPPr>
-              <a:defRPr sz="975" b="0">
-                <a:solidFill>
-                  <a:srgbClr val="526575"/>
-                </a:solidFill>
-                <a:latin typeface="Aptos"/>
-                <a:ea typeface="Aptos"/>
-                <a:cs typeface="Aptos"/>
-              </a:defRPr>
-            </a:defPPr>
-          </a:lstStyle>
+          <a:lstStyle xmlns:a="http://schemas.openxmlformats.org/drawingml/2006/main"/>
           <a:p xmlns:a="http://schemas.openxmlformats.org/drawingml/2006/main">
             <a:pPr>
+              <a:buNone/>
               <a:defRPr sz="975" b="0">
                 <a:solidFill>
                   <a:srgbClr val="526575"/>
@@ -6841,20 +6453,10 @@
         </p:spPr>
         <p:txBody>
           <a:bodyPr xmlns:a="http://schemas.openxmlformats.org/drawingml/2006/main" anchor="ctr"/>
-          <a:lstStyle xmlns:a="http://schemas.openxmlformats.org/drawingml/2006/main">
-            <a:defPPr>
-              <a:defRPr sz="1725" b="1">
-                <a:solidFill>
-                  <a:srgbClr val="1C2935"/>
-                </a:solidFill>
-                <a:latin typeface="Aptos"/>
-                <a:ea typeface="Aptos"/>
-                <a:cs typeface="Aptos"/>
-              </a:defRPr>
-            </a:defPPr>
-          </a:lstStyle>
+          <a:lstStyle xmlns:a="http://schemas.openxmlformats.org/drawingml/2006/main"/>
           <a:p xmlns:a="http://schemas.openxmlformats.org/drawingml/2006/main">
             <a:pPr>
+              <a:buNone/>
               <a:defRPr sz="1725" b="1">
                 <a:solidFill>
                   <a:srgbClr val="1C2935"/>
@@ -6939,20 +6541,10 @@
         </p:spPr>
         <p:txBody>
           <a:bodyPr xmlns:a="http://schemas.openxmlformats.org/drawingml/2006/main" anchor="ctr"/>
-          <a:lstStyle xmlns:a="http://schemas.openxmlformats.org/drawingml/2006/main">
-            <a:defPPr>
-              <a:defRPr sz="1350" b="1">
-                <a:solidFill>
-                  <a:srgbClr val="15324B"/>
-                </a:solidFill>
-                <a:latin typeface="Aptos"/>
-                <a:ea typeface="Aptos"/>
-                <a:cs typeface="Aptos"/>
-              </a:defRPr>
-            </a:defPPr>
-          </a:lstStyle>
+          <a:lstStyle xmlns:a="http://schemas.openxmlformats.org/drawingml/2006/main"/>
           <a:p xmlns:a="http://schemas.openxmlformats.org/drawingml/2006/main">
             <a:pPr>
+              <a:buNone/>
               <a:defRPr sz="1350" b="1">
                 <a:solidFill>
                   <a:srgbClr val="15324B"/>
@@ -7006,20 +6598,10 @@
         </p:spPr>
         <p:txBody>
           <a:bodyPr xmlns:a="http://schemas.openxmlformats.org/drawingml/2006/main" anchor="ctr"/>
-          <a:lstStyle xmlns:a="http://schemas.openxmlformats.org/drawingml/2006/main">
-            <a:defPPr>
-              <a:defRPr sz="1350" b="0">
-                <a:solidFill>
-                  <a:srgbClr val="526575"/>
-                </a:solidFill>
-                <a:latin typeface="Aptos"/>
-                <a:ea typeface="Aptos"/>
-                <a:cs typeface="Aptos"/>
-              </a:defRPr>
-            </a:defPPr>
-          </a:lstStyle>
+          <a:lstStyle xmlns:a="http://schemas.openxmlformats.org/drawingml/2006/main"/>
           <a:p xmlns:a="http://schemas.openxmlformats.org/drawingml/2006/main">
             <a:pPr>
+              <a:buNone/>
               <a:defRPr sz="1350" b="0">
                 <a:solidFill>
                   <a:srgbClr val="526575"/>
@@ -7104,20 +6686,10 @@
         </p:spPr>
         <p:txBody>
           <a:bodyPr xmlns:a="http://schemas.openxmlformats.org/drawingml/2006/main" anchor="ctr"/>
-          <a:lstStyle xmlns:a="http://schemas.openxmlformats.org/drawingml/2006/main">
-            <a:defPPr>
-              <a:defRPr sz="1350" b="1">
-                <a:solidFill>
-                  <a:srgbClr val="15324B"/>
-                </a:solidFill>
-                <a:latin typeface="Aptos"/>
-                <a:ea typeface="Aptos"/>
-                <a:cs typeface="Aptos"/>
-              </a:defRPr>
-            </a:defPPr>
-          </a:lstStyle>
+          <a:lstStyle xmlns:a="http://schemas.openxmlformats.org/drawingml/2006/main"/>
           <a:p xmlns:a="http://schemas.openxmlformats.org/drawingml/2006/main">
             <a:pPr>
+              <a:buNone/>
               <a:defRPr sz="1350" b="1">
                 <a:solidFill>
                   <a:srgbClr val="15324B"/>
@@ -7171,20 +6743,10 @@
         </p:spPr>
         <p:txBody>
           <a:bodyPr xmlns:a="http://schemas.openxmlformats.org/drawingml/2006/main" anchor="ctr"/>
-          <a:lstStyle xmlns:a="http://schemas.openxmlformats.org/drawingml/2006/main">
-            <a:defPPr>
-              <a:defRPr sz="1350" b="0">
-                <a:solidFill>
-                  <a:srgbClr val="526575"/>
-                </a:solidFill>
-                <a:latin typeface="Aptos"/>
-                <a:ea typeface="Aptos"/>
-                <a:cs typeface="Aptos"/>
-              </a:defRPr>
-            </a:defPPr>
-          </a:lstStyle>
+          <a:lstStyle xmlns:a="http://schemas.openxmlformats.org/drawingml/2006/main"/>
           <a:p xmlns:a="http://schemas.openxmlformats.org/drawingml/2006/main">
             <a:pPr>
+              <a:buNone/>
               <a:defRPr sz="1350" b="0">
                 <a:solidFill>
                   <a:srgbClr val="526575"/>
@@ -7269,20 +6831,10 @@
         </p:spPr>
         <p:txBody>
           <a:bodyPr xmlns:a="http://schemas.openxmlformats.org/drawingml/2006/main" anchor="ctr"/>
-          <a:lstStyle xmlns:a="http://schemas.openxmlformats.org/drawingml/2006/main">
-            <a:defPPr>
-              <a:defRPr sz="1350" b="1">
-                <a:solidFill>
-                  <a:srgbClr val="15324B"/>
-                </a:solidFill>
-                <a:latin typeface="Aptos"/>
-                <a:ea typeface="Aptos"/>
-                <a:cs typeface="Aptos"/>
-              </a:defRPr>
-            </a:defPPr>
-          </a:lstStyle>
+          <a:lstStyle xmlns:a="http://schemas.openxmlformats.org/drawingml/2006/main"/>
           <a:p xmlns:a="http://schemas.openxmlformats.org/drawingml/2006/main">
             <a:pPr>
+              <a:buNone/>
               <a:defRPr sz="1350" b="1">
                 <a:solidFill>
                   <a:srgbClr val="15324B"/>
@@ -7336,20 +6888,10 @@
         </p:spPr>
         <p:txBody>
           <a:bodyPr xmlns:a="http://schemas.openxmlformats.org/drawingml/2006/main" anchor="ctr"/>
-          <a:lstStyle xmlns:a="http://schemas.openxmlformats.org/drawingml/2006/main">
-            <a:defPPr>
-              <a:defRPr sz="1350" b="0">
-                <a:solidFill>
-                  <a:srgbClr val="526575"/>
-                </a:solidFill>
-                <a:latin typeface="Aptos"/>
-                <a:ea typeface="Aptos"/>
-                <a:cs typeface="Aptos"/>
-              </a:defRPr>
-            </a:defPPr>
-          </a:lstStyle>
+          <a:lstStyle xmlns:a="http://schemas.openxmlformats.org/drawingml/2006/main"/>
           <a:p xmlns:a="http://schemas.openxmlformats.org/drawingml/2006/main">
             <a:pPr>
+              <a:buNone/>
               <a:defRPr sz="1350" b="0">
                 <a:solidFill>
                   <a:srgbClr val="526575"/>
@@ -7434,20 +6976,10 @@
         </p:spPr>
         <p:txBody>
           <a:bodyPr xmlns:a="http://schemas.openxmlformats.org/drawingml/2006/main" anchor="ctr"/>
-          <a:lstStyle xmlns:a="http://schemas.openxmlformats.org/drawingml/2006/main">
-            <a:defPPr>
-              <a:defRPr sz="1350" b="1">
-                <a:solidFill>
-                  <a:srgbClr val="15324B"/>
-                </a:solidFill>
-                <a:latin typeface="Aptos"/>
-                <a:ea typeface="Aptos"/>
-                <a:cs typeface="Aptos"/>
-              </a:defRPr>
-            </a:defPPr>
-          </a:lstStyle>
+          <a:lstStyle xmlns:a="http://schemas.openxmlformats.org/drawingml/2006/main"/>
           <a:p xmlns:a="http://schemas.openxmlformats.org/drawingml/2006/main">
             <a:pPr>
+              <a:buNone/>
               <a:defRPr sz="1350" b="1">
                 <a:solidFill>
                   <a:srgbClr val="15324B"/>
@@ -7501,20 +7033,10 @@
         </p:spPr>
         <p:txBody>
           <a:bodyPr xmlns:a="http://schemas.openxmlformats.org/drawingml/2006/main" anchor="ctr"/>
-          <a:lstStyle xmlns:a="http://schemas.openxmlformats.org/drawingml/2006/main">
-            <a:defPPr>
-              <a:defRPr sz="1350" b="0">
-                <a:solidFill>
-                  <a:srgbClr val="526575"/>
-                </a:solidFill>
-                <a:latin typeface="Aptos"/>
-                <a:ea typeface="Aptos"/>
-                <a:cs typeface="Aptos"/>
-              </a:defRPr>
-            </a:defPPr>
-          </a:lstStyle>
+          <a:lstStyle xmlns:a="http://schemas.openxmlformats.org/drawingml/2006/main"/>
           <a:p xmlns:a="http://schemas.openxmlformats.org/drawingml/2006/main">
             <a:pPr>
+              <a:buNone/>
               <a:defRPr sz="1350" b="0">
                 <a:solidFill>
                   <a:srgbClr val="526575"/>
@@ -7599,20 +7121,10 @@
         </p:spPr>
         <p:txBody>
           <a:bodyPr xmlns:a="http://schemas.openxmlformats.org/drawingml/2006/main" anchor="ctr"/>
-          <a:lstStyle xmlns:a="http://schemas.openxmlformats.org/drawingml/2006/main">
-            <a:defPPr>
-              <a:defRPr sz="1350" b="1">
-                <a:solidFill>
-                  <a:srgbClr val="15324B"/>
-                </a:solidFill>
-                <a:latin typeface="Aptos"/>
-                <a:ea typeface="Aptos"/>
-                <a:cs typeface="Aptos"/>
-              </a:defRPr>
-            </a:defPPr>
-          </a:lstStyle>
+          <a:lstStyle xmlns:a="http://schemas.openxmlformats.org/drawingml/2006/main"/>
           <a:p xmlns:a="http://schemas.openxmlformats.org/drawingml/2006/main">
             <a:pPr>
+              <a:buNone/>
               <a:defRPr sz="1350" b="1">
                 <a:solidFill>
                   <a:srgbClr val="15324B"/>
@@ -7666,20 +7178,10 @@
         </p:spPr>
         <p:txBody>
           <a:bodyPr xmlns:a="http://schemas.openxmlformats.org/drawingml/2006/main" anchor="ctr"/>
-          <a:lstStyle xmlns:a="http://schemas.openxmlformats.org/drawingml/2006/main">
-            <a:defPPr>
-              <a:defRPr sz="1350" b="0">
-                <a:solidFill>
-                  <a:srgbClr val="526575"/>
-                </a:solidFill>
-                <a:latin typeface="Aptos"/>
-                <a:ea typeface="Aptos"/>
-                <a:cs typeface="Aptos"/>
-              </a:defRPr>
-            </a:defPPr>
-          </a:lstStyle>
+          <a:lstStyle xmlns:a="http://schemas.openxmlformats.org/drawingml/2006/main"/>
           <a:p xmlns:a="http://schemas.openxmlformats.org/drawingml/2006/main">
             <a:pPr>
+              <a:buNone/>
               <a:defRPr sz="1350" b="0">
                 <a:solidFill>
                   <a:srgbClr val="526575"/>
@@ -7764,20 +7266,10 @@
         </p:spPr>
         <p:txBody>
           <a:bodyPr xmlns:a="http://schemas.openxmlformats.org/drawingml/2006/main" anchor="ctr"/>
-          <a:lstStyle xmlns:a="http://schemas.openxmlformats.org/drawingml/2006/main">
-            <a:defPPr>
-              <a:defRPr sz="1275" b="0">
-                <a:solidFill>
-                  <a:srgbClr val="1C2935"/>
-                </a:solidFill>
-                <a:latin typeface="Aptos"/>
-                <a:ea typeface="Aptos"/>
-                <a:cs typeface="Aptos"/>
-              </a:defRPr>
-            </a:defPPr>
-          </a:lstStyle>
+          <a:lstStyle xmlns:a="http://schemas.openxmlformats.org/drawingml/2006/main"/>
           <a:p xmlns:a="http://schemas.openxmlformats.org/drawingml/2006/main">
             <a:pPr>
+              <a:buNone/>
               <a:defRPr sz="1275" b="0">
                 <a:solidFill>
                   <a:srgbClr val="1C2935"/>
@@ -7831,20 +7323,10 @@
         </p:spPr>
         <p:txBody>
           <a:bodyPr xmlns:a="http://schemas.openxmlformats.org/drawingml/2006/main" anchor="ctr"/>
-          <a:lstStyle xmlns:a="http://schemas.openxmlformats.org/drawingml/2006/main">
-            <a:defPPr>
-              <a:defRPr sz="1200" b="0">
-                <a:solidFill>
-                  <a:srgbClr val="AA5E57"/>
-                </a:solidFill>
-                <a:latin typeface="Aptos"/>
-                <a:ea typeface="Aptos"/>
-                <a:cs typeface="Aptos"/>
-              </a:defRPr>
-            </a:defPPr>
-          </a:lstStyle>
+          <a:lstStyle xmlns:a="http://schemas.openxmlformats.org/drawingml/2006/main"/>
           <a:p xmlns:a="http://schemas.openxmlformats.org/drawingml/2006/main">
             <a:pPr>
+              <a:buNone/>
               <a:defRPr sz="1200" b="0">
                 <a:solidFill>
                   <a:srgbClr val="AA5E57"/>
@@ -7927,20 +7409,10 @@
         </p:spPr>
         <p:txBody>
           <a:bodyPr xmlns:a="http://schemas.openxmlformats.org/drawingml/2006/main" anchor="ctr"/>
-          <a:lstStyle xmlns:a="http://schemas.openxmlformats.org/drawingml/2006/main">
-            <a:defPPr>
-              <a:defRPr sz="2700" b="1">
-                <a:solidFill>
-                  <a:srgbClr val="15324B"/>
-                </a:solidFill>
-                <a:latin typeface="Aptos"/>
-                <a:ea typeface="Aptos"/>
-                <a:cs typeface="Aptos"/>
-              </a:defRPr>
-            </a:defPPr>
-          </a:lstStyle>
+          <a:lstStyle xmlns:a="http://schemas.openxmlformats.org/drawingml/2006/main"/>
           <a:p xmlns:a="http://schemas.openxmlformats.org/drawingml/2006/main">
             <a:pPr>
+              <a:buNone/>
               <a:defRPr sz="2700" b="1">
                 <a:solidFill>
                   <a:srgbClr val="15324B"/>
@@ -8025,20 +7497,10 @@
         </p:spPr>
         <p:txBody>
           <a:bodyPr xmlns:a="http://schemas.openxmlformats.org/drawingml/2006/main" anchor="ctr"/>
-          <a:lstStyle xmlns:a="http://schemas.openxmlformats.org/drawingml/2006/main">
-            <a:defPPr>
-              <a:defRPr sz="975" b="0">
-                <a:solidFill>
-                  <a:srgbClr val="526575"/>
-                </a:solidFill>
-                <a:latin typeface="Aptos"/>
-                <a:ea typeface="Aptos"/>
-                <a:cs typeface="Aptos"/>
-              </a:defRPr>
-            </a:defPPr>
-          </a:lstStyle>
+          <a:lstStyle xmlns:a="http://schemas.openxmlformats.org/drawingml/2006/main"/>
           <a:p xmlns:a="http://schemas.openxmlformats.org/drawingml/2006/main">
             <a:pPr>
+              <a:buNone/>
               <a:defRPr sz="975" b="0">
                 <a:solidFill>
                   <a:srgbClr val="526575"/>
@@ -8064,20 +7526,14 @@
       </p:sp>
       <p:pic>
         <p:nvPicPr>
-          <p:cNvPr id="4" name="">
-            <a:extLst xmlns:a="http://schemas.openxmlformats.org/drawingml/2006/main">
-              <a:ext uri="{FF2B5EF4-FFF2-40B4-BE49-F238E27FC236}">
-                <a16:creationId xmlns:a16="http://schemas.microsoft.com/office/drawing/2014/main" id="{B3A9D157-27A6-4CD2-904D-9F02ACA68A13}"/>
-              </a:ext>
-            </a:extLst>
-          </p:cNvPr>
+          <p:cNvPr id="15" name=""/>
           <p:cNvPicPr>
             <a:picLocks xmlns:a="http://schemas.openxmlformats.org/drawingml/2006/main" noChangeAspect="1"/>
           </p:cNvPicPr>
           <p:nvPr/>
         </p:nvPicPr>
         <p:blipFill>
-          <a:blip xmlns:r="http://schemas.openxmlformats.org/officeDocument/2006/relationships" xmlns:a="http://schemas.openxmlformats.org/drawingml/2006/main" r:embed="R78ba4f5242574a8c"/>
+          <a:blip xmlns:r="http://schemas.openxmlformats.org/officeDocument/2006/relationships" xmlns:a="http://schemas.openxmlformats.org/drawingml/2006/main" r:embed="Rec44f0e67f4444d3"/>
           <a:stretch xmlns:a="http://schemas.openxmlformats.org/drawingml/2006/main"/>
         </p:blipFill>
         <p:spPr>
@@ -8120,20 +7576,10 @@
         </p:spPr>
         <p:txBody>
           <a:bodyPr xmlns:a="http://schemas.openxmlformats.org/drawingml/2006/main" anchor="ctr"/>
-          <a:lstStyle xmlns:a="http://schemas.openxmlformats.org/drawingml/2006/main">
-            <a:defPPr>
-              <a:defRPr sz="1650" b="1">
-                <a:solidFill>
-                  <a:srgbClr val="157A78"/>
-                </a:solidFill>
-                <a:latin typeface="Aptos"/>
-                <a:ea typeface="Aptos"/>
-                <a:cs typeface="Aptos"/>
-              </a:defRPr>
-            </a:defPPr>
-          </a:lstStyle>
+          <a:lstStyle xmlns:a="http://schemas.openxmlformats.org/drawingml/2006/main"/>
           <a:p xmlns:a="http://schemas.openxmlformats.org/drawingml/2006/main">
             <a:pPr>
+              <a:buNone/>
               <a:defRPr sz="1650" b="1">
                 <a:solidFill>
                   <a:srgbClr val="157A78"/>
@@ -8187,20 +7633,10 @@
         </p:spPr>
         <p:txBody>
           <a:bodyPr xmlns:a="http://schemas.openxmlformats.org/drawingml/2006/main" anchor="ctr"/>
-          <a:lstStyle xmlns:a="http://schemas.openxmlformats.org/drawingml/2006/main">
-            <a:defPPr>
-              <a:defRPr sz="1575" b="0">
-                <a:solidFill>
-                  <a:srgbClr val="1C2935"/>
-                </a:solidFill>
-                <a:latin typeface="Aptos"/>
-                <a:ea typeface="Aptos"/>
-                <a:cs typeface="Aptos"/>
-              </a:defRPr>
-            </a:defPPr>
-          </a:lstStyle>
+          <a:lstStyle xmlns:a="http://schemas.openxmlformats.org/drawingml/2006/main"/>
           <a:p xmlns:a="http://schemas.openxmlformats.org/drawingml/2006/main">
             <a:pPr>
+              <a:buNone/>
               <a:defRPr sz="1575" b="0">
                 <a:solidFill>
                   <a:srgbClr val="1C2935"/>
@@ -8224,6 +7660,7 @@
           </a:p>
           <a:p xmlns:a="http://schemas.openxmlformats.org/drawingml/2006/main">
             <a:pPr>
+              <a:buNone/>
               <a:defRPr sz="1575" b="0">
                 <a:solidFill>
                   <a:srgbClr val="1C2935"/>
@@ -8277,20 +7714,10 @@
         </p:spPr>
         <p:txBody>
           <a:bodyPr xmlns:a="http://schemas.openxmlformats.org/drawingml/2006/main" anchor="ctr"/>
-          <a:lstStyle xmlns:a="http://schemas.openxmlformats.org/drawingml/2006/main">
-            <a:defPPr>
-              <a:defRPr sz="1575" b="0">
-                <a:solidFill>
-                  <a:srgbClr val="1C2935"/>
-                </a:solidFill>
-                <a:latin typeface="Aptos"/>
-                <a:ea typeface="Aptos"/>
-                <a:cs typeface="Aptos"/>
-              </a:defRPr>
-            </a:defPPr>
-          </a:lstStyle>
+          <a:lstStyle xmlns:a="http://schemas.openxmlformats.org/drawingml/2006/main"/>
           <a:p xmlns:a="http://schemas.openxmlformats.org/drawingml/2006/main">
             <a:pPr>
+              <a:buNone/>
               <a:defRPr sz="1575" b="0">
                 <a:solidFill>
                   <a:srgbClr val="1C2935"/>
@@ -8314,6 +7741,7 @@
           </a:p>
           <a:p xmlns:a="http://schemas.openxmlformats.org/drawingml/2006/main">
             <a:pPr>
+              <a:buNone/>
               <a:defRPr sz="1575" b="0">
                 <a:solidFill>
                   <a:srgbClr val="1C2935"/>
@@ -8367,20 +7795,10 @@
         </p:spPr>
         <p:txBody>
           <a:bodyPr xmlns:a="http://schemas.openxmlformats.org/drawingml/2006/main" anchor="ctr"/>
-          <a:lstStyle xmlns:a="http://schemas.openxmlformats.org/drawingml/2006/main">
-            <a:defPPr>
-              <a:defRPr sz="1500" b="1">
-                <a:solidFill>
-                  <a:srgbClr val="15324B"/>
-                </a:solidFill>
-                <a:latin typeface="Aptos"/>
-                <a:ea typeface="Aptos"/>
-                <a:cs typeface="Aptos"/>
-              </a:defRPr>
-            </a:defPPr>
-          </a:lstStyle>
+          <a:lstStyle xmlns:a="http://schemas.openxmlformats.org/drawingml/2006/main"/>
           <a:p xmlns:a="http://schemas.openxmlformats.org/drawingml/2006/main">
             <a:pPr>
+              <a:buNone/>
               <a:defRPr sz="1500" b="1">
                 <a:solidFill>
                   <a:srgbClr val="15324B"/>
@@ -8434,20 +7852,10 @@
         </p:spPr>
         <p:txBody>
           <a:bodyPr xmlns:a="http://schemas.openxmlformats.org/drawingml/2006/main" anchor="ctr"/>
-          <a:lstStyle xmlns:a="http://schemas.openxmlformats.org/drawingml/2006/main">
-            <a:defPPr>
-              <a:defRPr sz="1200" b="0">
-                <a:solidFill>
-                  <a:srgbClr val="AA5E57"/>
-                </a:solidFill>
-                <a:latin typeface="Aptos"/>
-                <a:ea typeface="Aptos"/>
-                <a:cs typeface="Aptos"/>
-              </a:defRPr>
-            </a:defPPr>
-          </a:lstStyle>
+          <a:lstStyle xmlns:a="http://schemas.openxmlformats.org/drawingml/2006/main"/>
           <a:p xmlns:a="http://schemas.openxmlformats.org/drawingml/2006/main">
             <a:pPr>
+              <a:buNone/>
               <a:defRPr sz="1200" b="0">
                 <a:solidFill>
                   <a:srgbClr val="AA5E57"/>
@@ -8530,20 +7938,10 @@
         </p:spPr>
         <p:txBody>
           <a:bodyPr xmlns:a="http://schemas.openxmlformats.org/drawingml/2006/main" anchor="ctr"/>
-          <a:lstStyle xmlns:a="http://schemas.openxmlformats.org/drawingml/2006/main">
-            <a:defPPr>
-              <a:defRPr sz="2700" b="1">
-                <a:solidFill>
-                  <a:srgbClr val="15324B"/>
-                </a:solidFill>
-                <a:latin typeface="Aptos"/>
-                <a:ea typeface="Aptos"/>
-                <a:cs typeface="Aptos"/>
-              </a:defRPr>
-            </a:defPPr>
-          </a:lstStyle>
+          <a:lstStyle xmlns:a="http://schemas.openxmlformats.org/drawingml/2006/main"/>
           <a:p xmlns:a="http://schemas.openxmlformats.org/drawingml/2006/main">
             <a:pPr>
+              <a:buNone/>
               <a:defRPr sz="2700" b="1">
                 <a:solidFill>
                   <a:srgbClr val="15324B"/>
@@ -8562,7 +7960,7 @@
                 <a:ea typeface="Aptos"/>
                 <a:cs typeface="Aptos"/>
               </a:rPr>
-              <a:t>Conclusion and live demonstration</a:t>
+              <a:t>Conclusion and nested tuning results</a:t>
             </a:r>
           </a:p>
         </p:txBody>
@@ -8628,20 +8026,10 @@
         </p:spPr>
         <p:txBody>
           <a:bodyPr xmlns:a="http://schemas.openxmlformats.org/drawingml/2006/main" anchor="ctr"/>
-          <a:lstStyle xmlns:a="http://schemas.openxmlformats.org/drawingml/2006/main">
-            <a:defPPr>
-              <a:defRPr sz="975" b="0">
-                <a:solidFill>
-                  <a:srgbClr val="526575"/>
-                </a:solidFill>
-                <a:latin typeface="Aptos"/>
-                <a:ea typeface="Aptos"/>
-                <a:cs typeface="Aptos"/>
-              </a:defRPr>
-            </a:defPPr>
-          </a:lstStyle>
+          <a:lstStyle xmlns:a="http://schemas.openxmlformats.org/drawingml/2006/main"/>
           <a:p xmlns:a="http://schemas.openxmlformats.org/drawingml/2006/main">
             <a:pPr>
+              <a:buNone/>
               <a:defRPr sz="975" b="0">
                 <a:solidFill>
                   <a:srgbClr val="526575"/>
@@ -8695,20 +8083,10 @@
         </p:spPr>
         <p:txBody>
           <a:bodyPr xmlns:a="http://schemas.openxmlformats.org/drawingml/2006/main" anchor="ctr"/>
-          <a:lstStyle xmlns:a="http://schemas.openxmlformats.org/drawingml/2006/main">
-            <a:defPPr>
-              <a:defRPr sz="1650" b="1">
-                <a:solidFill>
-                  <a:srgbClr val="157A78"/>
-                </a:solidFill>
-                <a:latin typeface="Aptos"/>
-                <a:ea typeface="Aptos"/>
-                <a:cs typeface="Aptos"/>
-              </a:defRPr>
-            </a:defPPr>
-          </a:lstStyle>
+          <a:lstStyle xmlns:a="http://schemas.openxmlformats.org/drawingml/2006/main"/>
           <a:p xmlns:a="http://schemas.openxmlformats.org/drawingml/2006/main">
             <a:pPr>
+              <a:buNone/>
               <a:defRPr sz="1650" b="1">
                 <a:solidFill>
                   <a:srgbClr val="157A78"/>
@@ -8762,20 +8140,10 @@
         </p:spPr>
         <p:txBody>
           <a:bodyPr xmlns:a="http://schemas.openxmlformats.org/drawingml/2006/main" anchor="ctr"/>
-          <a:lstStyle xmlns:a="http://schemas.openxmlformats.org/drawingml/2006/main">
-            <a:defPPr>
-              <a:defRPr sz="1650" b="0">
-                <a:solidFill>
-                  <a:srgbClr val="1C2935"/>
-                </a:solidFill>
-                <a:latin typeface="Aptos"/>
-                <a:ea typeface="Aptos"/>
-                <a:cs typeface="Aptos"/>
-              </a:defRPr>
-            </a:defPPr>
-          </a:lstStyle>
+          <a:lstStyle xmlns:a="http://schemas.openxmlformats.org/drawingml/2006/main"/>
           <a:p xmlns:a="http://schemas.openxmlformats.org/drawingml/2006/main">
             <a:pPr>
+              <a:buNone/>
               <a:defRPr sz="1650" b="0">
                 <a:solidFill>
                   <a:srgbClr val="1C2935"/>
@@ -8829,20 +8197,10 @@
         </p:spPr>
         <p:txBody>
           <a:bodyPr xmlns:a="http://schemas.openxmlformats.org/drawingml/2006/main" anchor="ctr"/>
-          <a:lstStyle xmlns:a="http://schemas.openxmlformats.org/drawingml/2006/main">
-            <a:defPPr>
-              <a:defRPr sz="1650" b="1">
-                <a:solidFill>
-                  <a:srgbClr val="157A78"/>
-                </a:solidFill>
-                <a:latin typeface="Aptos"/>
-                <a:ea typeface="Aptos"/>
-                <a:cs typeface="Aptos"/>
-              </a:defRPr>
-            </a:defPPr>
-          </a:lstStyle>
+          <a:lstStyle xmlns:a="http://schemas.openxmlformats.org/drawingml/2006/main"/>
           <a:p xmlns:a="http://schemas.openxmlformats.org/drawingml/2006/main">
             <a:pPr>
+              <a:buNone/>
               <a:defRPr sz="1650" b="1">
                 <a:solidFill>
                   <a:srgbClr val="157A78"/>
@@ -8896,20 +8254,10 @@
         </p:spPr>
         <p:txBody>
           <a:bodyPr xmlns:a="http://schemas.openxmlformats.org/drawingml/2006/main" anchor="ctr"/>
-          <a:lstStyle xmlns:a="http://schemas.openxmlformats.org/drawingml/2006/main">
-            <a:defPPr>
-              <a:defRPr sz="1650" b="0">
-                <a:solidFill>
-                  <a:srgbClr val="1C2935"/>
-                </a:solidFill>
-                <a:latin typeface="Aptos"/>
-                <a:ea typeface="Aptos"/>
-                <a:cs typeface="Aptos"/>
-              </a:defRPr>
-            </a:defPPr>
-          </a:lstStyle>
+          <a:lstStyle xmlns:a="http://schemas.openxmlformats.org/drawingml/2006/main"/>
           <a:p xmlns:a="http://schemas.openxmlformats.org/drawingml/2006/main">
             <a:pPr>
+              <a:buNone/>
               <a:defRPr sz="1650" b="0">
                 <a:solidFill>
                   <a:srgbClr val="1C2935"/>
@@ -8928,7 +8276,7 @@
                 <a:ea typeface="Aptos"/>
                 <a:cs typeface="Aptos"/>
               </a:rPr>
-              <a:t>Logistic Regression reached 0.642 balanced accuracy at 270 days; clinical Cox C-index was 0.522.</a:t>
+              <a:t>TCGA: tuned Naive Bayes 0.606 (fixed 0.574); tuned Logistic Regression 0.624 (fixed 0.642).</a:t>
             </a:r>
           </a:p>
         </p:txBody>
@@ -8963,20 +8311,10 @@
         </p:spPr>
         <p:txBody>
           <a:bodyPr xmlns:a="http://schemas.openxmlformats.org/drawingml/2006/main" anchor="ctr"/>
-          <a:lstStyle xmlns:a="http://schemas.openxmlformats.org/drawingml/2006/main">
-            <a:defPPr>
-              <a:defRPr sz="1650" b="1">
-                <a:solidFill>
-                  <a:srgbClr val="157A78"/>
-                </a:solidFill>
-                <a:latin typeface="Aptos"/>
-                <a:ea typeface="Aptos"/>
-                <a:cs typeface="Aptos"/>
-              </a:defRPr>
-            </a:defPPr>
-          </a:lstStyle>
+          <a:lstStyle xmlns:a="http://schemas.openxmlformats.org/drawingml/2006/main"/>
           <a:p xmlns:a="http://schemas.openxmlformats.org/drawingml/2006/main">
             <a:pPr>
+              <a:buNone/>
               <a:defRPr sz="1650" b="1">
                 <a:solidFill>
                   <a:srgbClr val="157A78"/>
@@ -9030,20 +8368,10 @@
         </p:spPr>
         <p:txBody>
           <a:bodyPr xmlns:a="http://schemas.openxmlformats.org/drawingml/2006/main" anchor="ctr"/>
-          <a:lstStyle xmlns:a="http://schemas.openxmlformats.org/drawingml/2006/main">
-            <a:defPPr>
-              <a:defRPr sz="1650" b="0">
-                <a:solidFill>
-                  <a:srgbClr val="1C2935"/>
-                </a:solidFill>
-                <a:latin typeface="Aptos"/>
-                <a:ea typeface="Aptos"/>
-                <a:cs typeface="Aptos"/>
-              </a:defRPr>
-            </a:defPPr>
-          </a:lstStyle>
+          <a:lstStyle xmlns:a="http://schemas.openxmlformats.org/drawingml/2006/main"/>
           <a:p xmlns:a="http://schemas.openxmlformats.org/drawingml/2006/main">
             <a:pPr>
+              <a:buNone/>
               <a:defRPr sz="1650" b="0">
                 <a:solidFill>
                   <a:srgbClr val="1C2935"/>
@@ -9062,7 +8390,7 @@
                 <a:ea typeface="Aptos"/>
                 <a:cs typeface="Aptos"/>
               </a:rPr>
-              <a:t>Scores are modest and cohort-specific. This is a methods exercise, not a clinical prediction tool.</a:t>
+              <a:t>MSK: tuned SVM 0.661 (fixed 0.652); Random Forest 0.658 (fixed 0.590). Cohorts are separate, not a direct gain.</a:t>
             </a:r>
           </a:p>
         </p:txBody>
@@ -9097,20 +8425,10 @@
         </p:spPr>
         <p:txBody>
           <a:bodyPr xmlns:a="http://schemas.openxmlformats.org/drawingml/2006/main" anchor="ctr"/>
-          <a:lstStyle xmlns:a="http://schemas.openxmlformats.org/drawingml/2006/main">
-            <a:defPPr>
-              <a:defRPr sz="1575" b="1">
-                <a:solidFill>
-                  <a:srgbClr val="157A78"/>
-                </a:solidFill>
-                <a:latin typeface="Aptos"/>
-                <a:ea typeface="Aptos"/>
-                <a:cs typeface="Aptos"/>
-              </a:defRPr>
-            </a:defPPr>
-          </a:lstStyle>
+          <a:lstStyle xmlns:a="http://schemas.openxmlformats.org/drawingml/2006/main"/>
           <a:p xmlns:a="http://schemas.openxmlformats.org/drawingml/2006/main">
             <a:pPr>
+              <a:buNone/>
               <a:defRPr sz="1575" b="1">
                 <a:solidFill>
                   <a:srgbClr val="157A78"/>
@@ -9195,20 +8513,10 @@
         </p:spPr>
         <p:txBody>
           <a:bodyPr xmlns:a="http://schemas.openxmlformats.org/drawingml/2006/main" anchor="ctr"/>
-          <a:lstStyle xmlns:a="http://schemas.openxmlformats.org/drawingml/2006/main">
-            <a:defPPr>
-              <a:defRPr sz="1275" b="0">
-                <a:solidFill>
-                  <a:srgbClr val="15324B"/>
-                </a:solidFill>
-                <a:latin typeface="Aptos"/>
-                <a:ea typeface="Aptos"/>
-                <a:cs typeface="Aptos"/>
-              </a:defRPr>
-            </a:defPPr>
-          </a:lstStyle>
+          <a:lstStyle xmlns:a="http://schemas.openxmlformats.org/drawingml/2006/main"/>
           <a:p xmlns:a="http://schemas.openxmlformats.org/drawingml/2006/main">
             <a:pPr>
+              <a:buNone/>
               <a:defRPr sz="1275" b="0">
                 <a:solidFill>
                   <a:srgbClr val="15324B"/>
@@ -9262,20 +8570,10 @@
         </p:spPr>
         <p:txBody>
           <a:bodyPr xmlns:a="http://schemas.openxmlformats.org/drawingml/2006/main" anchor="ctr"/>
-          <a:lstStyle xmlns:a="http://schemas.openxmlformats.org/drawingml/2006/main">
-            <a:defPPr>
-              <a:defRPr sz="1275" b="0">
-                <a:solidFill>
-                  <a:srgbClr val="526575"/>
-                </a:solidFill>
-                <a:latin typeface="Aptos"/>
-                <a:ea typeface="Aptos"/>
-                <a:cs typeface="Aptos"/>
-              </a:defRPr>
-            </a:defPPr>
-          </a:lstStyle>
+          <a:lstStyle xmlns:a="http://schemas.openxmlformats.org/drawingml/2006/main"/>
           <a:p xmlns:a="http://schemas.openxmlformats.org/drawingml/2006/main">
             <a:pPr>
+              <a:buNone/>
               <a:defRPr sz="1275" b="0">
                 <a:solidFill>
                   <a:srgbClr val="526575"/>
@@ -9294,7 +8592,7 @@
                 <a:ea typeface="Aptos"/>
                 <a:cs typeface="Aptos"/>
               </a:rPr>
-              <a:t>Outputs: classifier metrics · threshold sweep · survival C-index · two-page summary</a:t>
+              <a:t>Outputs: baseline and nested-CV metrics · fold parameters · survival C-index · two-page summary</a:t>
             </a:r>
           </a:p>
         </p:txBody>

</xml_diff>